<commit_message>
Refactor core fetch to frontend stream
</commit_message>
<xml_diff>
--- a/core/docs/wasp1_core_design.pptx
+++ b/core/docs/wasp1_core_design.pptx
@@ -2,22 +2,22 @@
 <file path=ppt/presentation.xml><?xml version="1.0" encoding="utf-8"?>
 <p:presentation xmlns:p="http://schemas.openxmlformats.org/presentationml/2006/main">
   <p:sldMasterIdLst>
-    <p:sldMasterId xmlns:r="http://schemas.openxmlformats.org/officeDocument/2006/relationships" id="2147483648" r:id="Ra916f6e624314ea7"/>
+    <p:sldMasterId xmlns:r="http://schemas.openxmlformats.org/officeDocument/2006/relationships" id="2147483648" r:id="R70576c2ba35b4c22"/>
   </p:sldMasterIdLst>
   <p:notesMasterIdLst>
-    <p:notesMasterId xmlns:r="http://schemas.openxmlformats.org/officeDocument/2006/relationships" r:id="R05d05cb963114735"/>
+    <p:notesMasterId xmlns:r="http://schemas.openxmlformats.org/officeDocument/2006/relationships" r:id="Rec9da2b17e304f66"/>
   </p:notesMasterIdLst>
   <p:sldIdLst>
-    <p:sldId xmlns:r="http://schemas.openxmlformats.org/officeDocument/2006/relationships" id="256" r:id="R6b28826b445d4fd9"/>
-    <p:sldId xmlns:r="http://schemas.openxmlformats.org/officeDocument/2006/relationships" id="257" r:id="R5750bc9c78414b9c"/>
-    <p:sldId xmlns:r="http://schemas.openxmlformats.org/officeDocument/2006/relationships" id="258" r:id="R51e46ddf72a24f1a"/>
-    <p:sldId xmlns:r="http://schemas.openxmlformats.org/officeDocument/2006/relationships" id="259" r:id="R264fbf55a8e64e50"/>
-    <p:sldId xmlns:r="http://schemas.openxmlformats.org/officeDocument/2006/relationships" id="260" r:id="Rd4c056d199e34e17"/>
-    <p:sldId xmlns:r="http://schemas.openxmlformats.org/officeDocument/2006/relationships" id="261" r:id="R54f9d64741cd4d10"/>
-    <p:sldId xmlns:r="http://schemas.openxmlformats.org/officeDocument/2006/relationships" id="262" r:id="R23c0451b9997488a"/>
-    <p:sldId xmlns:r="http://schemas.openxmlformats.org/officeDocument/2006/relationships" id="263" r:id="R56a08a12c2474d64"/>
-    <p:sldId xmlns:r="http://schemas.openxmlformats.org/officeDocument/2006/relationships" id="264" r:id="R16bc81e9205c4730"/>
-    <p:sldId xmlns:r="http://schemas.openxmlformats.org/officeDocument/2006/relationships" id="265" r:id="R5bc7292289ad403a"/>
+    <p:sldId xmlns:r="http://schemas.openxmlformats.org/officeDocument/2006/relationships" id="256" r:id="R4c554a9600a54730"/>
+    <p:sldId xmlns:r="http://schemas.openxmlformats.org/officeDocument/2006/relationships" id="257" r:id="R2c3067a2150e4a61"/>
+    <p:sldId xmlns:r="http://schemas.openxmlformats.org/officeDocument/2006/relationships" id="258" r:id="R9fabb11f42a44707"/>
+    <p:sldId xmlns:r="http://schemas.openxmlformats.org/officeDocument/2006/relationships" id="259" r:id="R5c2cf8d49e6e4c4d"/>
+    <p:sldId xmlns:r="http://schemas.openxmlformats.org/officeDocument/2006/relationships" id="260" r:id="Rda22d637fe324ff8"/>
+    <p:sldId xmlns:r="http://schemas.openxmlformats.org/officeDocument/2006/relationships" id="261" r:id="Ra2ae432d37284797"/>
+    <p:sldId xmlns:r="http://schemas.openxmlformats.org/officeDocument/2006/relationships" id="262" r:id="Rf30e0c42fd8743cf"/>
+    <p:sldId xmlns:r="http://schemas.openxmlformats.org/officeDocument/2006/relationships" id="263" r:id="Re18625b112034d3e"/>
+    <p:sldId xmlns:r="http://schemas.openxmlformats.org/officeDocument/2006/relationships" id="264" r:id="R808033081aa04dfb"/>
+    <p:sldId xmlns:r="http://schemas.openxmlformats.org/officeDocument/2006/relationships" id="265" r:id="Rbbcd00b0bf1040c7"/>
   </p:sldIdLst>
   <p:sldSz cx="12192000" cy="6858000"/>
   <p:notesSz cx="6858000" cy="9144000"/>
@@ -1204,7 +1204,7 @@
   </p:cSld>
   <p:clrMap bg1="lt1" tx1="dk1" bg2="lt2" tx2="dk2" accent1="accent1" accent2="accent2" accent3="accent3" accent4="accent4" accent5="accent5" accent6="accent6" hlink="hlink" folHlink="folHlink"/>
   <p:sldLayoutIdLst>
-    <p:sldLayoutId xmlns:r="http://schemas.openxmlformats.org/officeDocument/2006/relationships" id="2147483649" r:id="R13ba178f464a403c"/>
+    <p:sldLayoutId xmlns:r="http://schemas.openxmlformats.org/officeDocument/2006/relationships" id="2147483649" r:id="Rf51c0502d3c24683"/>
   </p:sldLayoutIdLst>
   <p:txStyles>
     <p:titleStyle>
@@ -1783,6 +1783,7 @@
           <a:lstStyle xmlns:a="http://schemas.openxmlformats.org/drawingml/2006/main"/>
           <a:p xmlns:a="http://schemas.openxmlformats.org/drawingml/2006/main">
             <a:pPr algn="l">
+              <a:buNone/>
               <a:defRPr sz="3750" b="1">
                 <a:solidFill>
                   <a:srgbClr val="111827"/>
@@ -1833,6 +1834,7 @@
           <a:lstStyle xmlns:a="http://schemas.openxmlformats.org/drawingml/2006/main"/>
           <a:p xmlns:a="http://schemas.openxmlformats.org/drawingml/2006/main">
             <a:pPr algn="l">
+              <a:buNone/>
               <a:defRPr sz="3000" b="1">
                 <a:solidFill>
                   <a:srgbClr val="111827"/>
@@ -1883,6 +1885,7 @@
           <a:lstStyle xmlns:a="http://schemas.openxmlformats.org/drawingml/2006/main"/>
           <a:p xmlns:a="http://schemas.openxmlformats.org/drawingml/2006/main">
             <a:pPr algn="l">
+              <a:buNone/>
               <a:defRPr sz="1575" b="0">
                 <a:solidFill>
                   <a:srgbClr val="64748B"/>
@@ -1933,6 +1936,7 @@
           <a:lstStyle xmlns:a="http://schemas.openxmlformats.org/drawingml/2006/main"/>
           <a:p xmlns:a="http://schemas.openxmlformats.org/drawingml/2006/main">
             <a:pPr algn="l">
+              <a:buNone/>
               <a:defRPr sz="1800" b="1">
                 <a:solidFill>
                   <a:srgbClr val="2563EB"/>
@@ -2018,6 +2022,7 @@
           <a:lstStyle xmlns:a="http://schemas.openxmlformats.org/drawingml/2006/main"/>
           <a:p xmlns:a="http://schemas.openxmlformats.org/drawingml/2006/main">
             <a:pPr algn="l">
+              <a:buNone/>
               <a:defRPr sz="1200" b="0">
                 <a:solidFill>
                   <a:srgbClr val="334155"/>
@@ -2103,6 +2108,7 @@
           <a:lstStyle xmlns:a="http://schemas.openxmlformats.org/drawingml/2006/main"/>
           <a:p xmlns:a="http://schemas.openxmlformats.org/drawingml/2006/main">
             <a:pPr algn="l">
+              <a:buNone/>
               <a:defRPr sz="1200" b="0">
                 <a:solidFill>
                   <a:srgbClr val="334155"/>
@@ -2188,6 +2194,7 @@
           <a:lstStyle xmlns:a="http://schemas.openxmlformats.org/drawingml/2006/main"/>
           <a:p xmlns:a="http://schemas.openxmlformats.org/drawingml/2006/main">
             <a:pPr algn="l">
+              <a:buNone/>
               <a:defRPr sz="1200" b="0">
                 <a:solidFill>
                   <a:srgbClr val="334155"/>
@@ -2273,6 +2280,7 @@
           <a:lstStyle xmlns:a="http://schemas.openxmlformats.org/drawingml/2006/main"/>
           <a:p xmlns:a="http://schemas.openxmlformats.org/drawingml/2006/main">
             <a:pPr algn="l">
+              <a:buNone/>
               <a:defRPr sz="1200" b="0">
                 <a:solidFill>
                   <a:srgbClr val="334155"/>
@@ -2307,7 +2315,7 @@
         <p:spPr>
           <a:xfrm xmlns:a="http://schemas.openxmlformats.org/drawingml/2006/main">
             <a:off x="7048500" y="742950"/>
-            <a:ext cx="4095750" cy="4572000"/>
+            <a:ext cx="4762500" cy="4572000"/>
           </a:xfrm>
           <a:prstGeom xmlns:a="http://schemas.openxmlformats.org/drawingml/2006/main" prst="roundRect">
             <a:avLst>
@@ -2348,7 +2356,7 @@
         <p:spPr>
           <a:xfrm xmlns:a="http://schemas.openxmlformats.org/drawingml/2006/main">
             <a:off x="7334250" y="1200150"/>
-            <a:ext cx="1762125" cy="647700"/>
+            <a:ext cx="1381125" cy="647700"/>
           </a:xfrm>
           <a:prstGeom xmlns:a="http://schemas.openxmlformats.org/drawingml/2006/main" prst="roundRect">
             <a:avLst>
@@ -2370,6 +2378,7 @@
           <a:lstStyle xmlns:a="http://schemas.openxmlformats.org/drawingml/2006/main"/>
           <a:p xmlns:a="http://schemas.openxmlformats.org/drawingml/2006/main">
             <a:pPr algn="ctr">
+              <a:buNone/>
               <a:defRPr sz="1050" b="1">
                 <a:solidFill>
                   <a:srgbClr val="2563EB"/>
@@ -2382,11 +2391,12 @@
                   <a:srgbClr val="2563EB"/>
                 </a:solidFill>
               </a:rPr>
-              <a:t>if req/rsp</a:t>
+              <a:t>frontend instr</a:t>
             </a:r>
           </a:p>
           <a:p xmlns:a="http://schemas.openxmlformats.org/drawingml/2006/main">
             <a:pPr algn="ctr">
+              <a:buNone/>
               <a:defRPr sz="1050" b="1">
                 <a:solidFill>
                   <a:srgbClr val="2563EB"/>
@@ -2399,7 +2409,7 @@
                   <a:srgbClr val="2563EB"/>
                 </a:solidFill>
               </a:rPr>
-              <a:t>IF</a:t>
+              <a:t>IF stream</a:t>
             </a:r>
           </a:p>
         </p:txBody>
@@ -2420,8 +2430,8 @@
         </p:nvSpPr>
         <p:spPr>
           <a:xfrm xmlns:a="http://schemas.openxmlformats.org/drawingml/2006/main">
-            <a:off x="9382125" y="1200150"/>
-            <a:ext cx="1762125" cy="647700"/>
+            <a:off x="8810625" y="1200150"/>
+            <a:ext cx="1381125" cy="647700"/>
           </a:xfrm>
           <a:prstGeom xmlns:a="http://schemas.openxmlformats.org/drawingml/2006/main" prst="roundRect">
             <a:avLst>
@@ -2443,6 +2453,7 @@
           <a:lstStyle xmlns:a="http://schemas.openxmlformats.org/drawingml/2006/main"/>
           <a:p xmlns:a="http://schemas.openxmlformats.org/drawingml/2006/main">
             <a:pPr algn="ctr">
+              <a:buNone/>
               <a:defRPr sz="1050" b="1">
                 <a:solidFill>
                   <a:srgbClr val="16A34A"/>
@@ -2460,6 +2471,7 @@
           </a:p>
           <a:p xmlns:a="http://schemas.openxmlformats.org/drawingml/2006/main">
             <a:pPr algn="ctr">
+              <a:buNone/>
               <a:defRPr sz="1050" b="1">
                 <a:solidFill>
                   <a:srgbClr val="16A34A"/>
@@ -2493,8 +2505,8 @@
         </p:nvSpPr>
         <p:spPr>
           <a:xfrm xmlns:a="http://schemas.openxmlformats.org/drawingml/2006/main">
-            <a:off x="11430000" y="1200150"/>
-            <a:ext cx="1762125" cy="647700"/>
+            <a:off x="10287000" y="1200150"/>
+            <a:ext cx="1381125" cy="647700"/>
           </a:xfrm>
           <a:prstGeom xmlns:a="http://schemas.openxmlformats.org/drawingml/2006/main" prst="roundRect">
             <a:avLst>
@@ -2516,6 +2528,7 @@
           <a:lstStyle xmlns:a="http://schemas.openxmlformats.org/drawingml/2006/main"/>
           <a:p xmlns:a="http://schemas.openxmlformats.org/drawingml/2006/main">
             <a:pPr algn="ctr">
+              <a:buNone/>
               <a:defRPr sz="1050" b="1">
                 <a:solidFill>
                   <a:srgbClr val="D97706"/>
@@ -2528,11 +2541,12 @@
                   <a:srgbClr val="D97706"/>
                 </a:solidFill>
               </a:rPr>
-              <a:t>decode/ALU/branch</a:t>
+              <a:t>decode/ALU/BR</a:t>
             </a:r>
           </a:p>
           <a:p xmlns:a="http://schemas.openxmlformats.org/drawingml/2006/main">
             <a:pPr algn="ctr">
+              <a:buNone/>
               <a:defRPr sz="1050" b="1">
                 <a:solidFill>
                   <a:srgbClr val="D97706"/>
@@ -2567,7 +2581,7 @@
         <p:spPr>
           <a:xfrm xmlns:a="http://schemas.openxmlformats.org/drawingml/2006/main">
             <a:off x="7334250" y="2114550"/>
-            <a:ext cx="1762125" cy="647700"/>
+            <a:ext cx="1381125" cy="647700"/>
           </a:xfrm>
           <a:prstGeom xmlns:a="http://schemas.openxmlformats.org/drawingml/2006/main" prst="roundRect">
             <a:avLst>
@@ -2589,6 +2603,7 @@
           <a:lstStyle xmlns:a="http://schemas.openxmlformats.org/drawingml/2006/main"/>
           <a:p xmlns:a="http://schemas.openxmlformats.org/drawingml/2006/main">
             <a:pPr algn="ctr">
+              <a:buNone/>
               <a:defRPr sz="1050" b="1">
                 <a:solidFill>
                   <a:srgbClr val="16A34A"/>
@@ -2606,6 +2621,7 @@
           </a:p>
           <a:p xmlns:a="http://schemas.openxmlformats.org/drawingml/2006/main">
             <a:pPr algn="ctr">
+              <a:buNone/>
               <a:defRPr sz="1050" b="1">
                 <a:solidFill>
                   <a:srgbClr val="16A34A"/>
@@ -2639,8 +2655,8 @@
         </p:nvSpPr>
         <p:spPr>
           <a:xfrm xmlns:a="http://schemas.openxmlformats.org/drawingml/2006/main">
-            <a:off x="9382125" y="2114550"/>
-            <a:ext cx="1762125" cy="647700"/>
+            <a:off x="8810625" y="2114550"/>
+            <a:ext cx="1381125" cy="647700"/>
           </a:xfrm>
           <a:prstGeom xmlns:a="http://schemas.openxmlformats.org/drawingml/2006/main" prst="roundRect">
             <a:avLst>
@@ -2662,6 +2678,7 @@
           <a:lstStyle xmlns:a="http://schemas.openxmlformats.org/drawingml/2006/main"/>
           <a:p xmlns:a="http://schemas.openxmlformats.org/drawingml/2006/main">
             <a:pPr algn="ctr">
+              <a:buNone/>
               <a:defRPr sz="1050" b="1">
                 <a:solidFill>
                   <a:srgbClr val="16A34A"/>
@@ -2679,6 +2696,7 @@
           </a:p>
           <a:p xmlns:a="http://schemas.openxmlformats.org/drawingml/2006/main">
             <a:pPr algn="ctr">
+              <a:buNone/>
               <a:defRPr sz="1050" b="1">
                 <a:solidFill>
                   <a:srgbClr val="16A34A"/>
@@ -2712,8 +2730,8 @@
         </p:nvSpPr>
         <p:spPr>
           <a:xfrm xmlns:a="http://schemas.openxmlformats.org/drawingml/2006/main">
-            <a:off x="11430000" y="2114550"/>
-            <a:ext cx="1762125" cy="647700"/>
+            <a:off x="10287000" y="2114550"/>
+            <a:ext cx="1381125" cy="647700"/>
           </a:xfrm>
           <a:prstGeom xmlns:a="http://schemas.openxmlformats.org/drawingml/2006/main" prst="roundRect">
             <a:avLst>
@@ -2735,6 +2753,7 @@
           <a:lstStyle xmlns:a="http://schemas.openxmlformats.org/drawingml/2006/main"/>
           <a:p xmlns:a="http://schemas.openxmlformats.org/drawingml/2006/main">
             <a:pPr algn="ctr">
+              <a:buNone/>
               <a:defRPr sz="1050" b="1">
                 <a:solidFill>
                   <a:srgbClr val="2563EB"/>
@@ -2752,6 +2771,7 @@
           </a:p>
           <a:p xmlns:a="http://schemas.openxmlformats.org/drawingml/2006/main">
             <a:pPr algn="ctr">
+              <a:buNone/>
               <a:defRPr sz="1050" b="1">
                 <a:solidFill>
                   <a:srgbClr val="2563EB"/>
@@ -2764,7 +2784,7 @@
                   <a:srgbClr val="2563EB"/>
                 </a:solidFill>
               </a:rPr>
-              <a:t>IF req/rsp</a:t>
+              <a:t>IF staged</a:t>
             </a:r>
           </a:p>
         </p:txBody>
@@ -2786,7 +2806,7 @@
         <p:spPr>
           <a:xfrm xmlns:a="http://schemas.openxmlformats.org/drawingml/2006/main">
             <a:off x="7334250" y="3028950"/>
-            <a:ext cx="1762125" cy="647700"/>
+            <a:ext cx="1381125" cy="647700"/>
           </a:xfrm>
           <a:prstGeom xmlns:a="http://schemas.openxmlformats.org/drawingml/2006/main" prst="roundRect">
             <a:avLst>
@@ -2808,6 +2828,7 @@
           <a:lstStyle xmlns:a="http://schemas.openxmlformats.org/drawingml/2006/main"/>
           <a:p xmlns:a="http://schemas.openxmlformats.org/drawingml/2006/main">
             <a:pPr algn="ctr">
+              <a:buNone/>
               <a:defRPr sz="1050" b="1">
                 <a:solidFill>
                   <a:srgbClr val="2563EB"/>
@@ -2820,11 +2841,12 @@
                   <a:srgbClr val="2563EB"/>
                 </a:solidFill>
               </a:rPr>
-              <a:t>commit/debug hooks</a:t>
+              <a:t>commit/debug</a:t>
             </a:r>
           </a:p>
           <a:p xmlns:a="http://schemas.openxmlformats.org/drawingml/2006/main">
             <a:pPr algn="ctr">
+              <a:buNone/>
               <a:defRPr sz="1050" b="1">
                 <a:solidFill>
                   <a:srgbClr val="2563EB"/>
@@ -2875,6 +2897,7 @@
           <a:lstStyle xmlns:a="http://schemas.openxmlformats.org/drawingml/2006/main"/>
           <a:p xmlns:a="http://schemas.openxmlformats.org/drawingml/2006/main">
             <a:pPr algn="l">
+              <a:buNone/>
               <a:defRPr sz="750" b="0">
                 <a:solidFill>
                   <a:srgbClr val="64748B"/>
@@ -2925,6 +2948,7 @@
           <a:lstStyle xmlns:a="http://schemas.openxmlformats.org/drawingml/2006/main"/>
           <a:p xmlns:a="http://schemas.openxmlformats.org/drawingml/2006/main">
             <a:pPr algn="r">
+              <a:buNone/>
               <a:defRPr sz="750" b="0">
                 <a:solidFill>
                   <a:srgbClr val="64748B"/>
@@ -3004,6 +3028,7 @@
           <a:lstStyle xmlns:a="http://schemas.openxmlformats.org/drawingml/2006/main"/>
           <a:p xmlns:a="http://schemas.openxmlformats.org/drawingml/2006/main">
             <a:pPr algn="l">
+              <a:buNone/>
               <a:defRPr sz="900" b="1">
                 <a:solidFill>
                   <a:srgbClr val="2563EB"/>
@@ -3054,6 +3079,7 @@
           <a:lstStyle xmlns:a="http://schemas.openxmlformats.org/drawingml/2006/main"/>
           <a:p xmlns:a="http://schemas.openxmlformats.org/drawingml/2006/main">
             <a:pPr algn="l">
+              <a:buNone/>
               <a:defRPr sz="2400" b="1">
                 <a:solidFill>
                   <a:srgbClr val="111827"/>
@@ -3110,6 +3136,7 @@
           <a:lstStyle xmlns:a="http://schemas.openxmlformats.org/drawingml/2006/main"/>
           <a:p xmlns:a="http://schemas.openxmlformats.org/drawingml/2006/main">
             <a:pPr algn="ctr">
+              <a:buNone/>
               <a:defRPr sz="1650" b="1">
                 <a:solidFill>
                   <a:srgbClr val="2563EB"/>
@@ -3195,6 +3222,7 @@
           <a:lstStyle xmlns:a="http://schemas.openxmlformats.org/drawingml/2006/main"/>
           <a:p xmlns:a="http://schemas.openxmlformats.org/drawingml/2006/main">
             <a:pPr algn="l">
+              <a:buNone/>
               <a:defRPr sz="1200" b="0">
                 <a:solidFill>
                   <a:srgbClr val="334155"/>
@@ -3280,6 +3308,7 @@
           <a:lstStyle xmlns:a="http://schemas.openxmlformats.org/drawingml/2006/main"/>
           <a:p xmlns:a="http://schemas.openxmlformats.org/drawingml/2006/main">
             <a:pPr algn="l">
+              <a:buNone/>
               <a:defRPr sz="1200" b="0">
                 <a:solidFill>
                   <a:srgbClr val="334155"/>
@@ -3365,6 +3394,7 @@
           <a:lstStyle xmlns:a="http://schemas.openxmlformats.org/drawingml/2006/main"/>
           <a:p xmlns:a="http://schemas.openxmlformats.org/drawingml/2006/main">
             <a:pPr algn="l">
+              <a:buNone/>
               <a:defRPr sz="1200" b="0">
                 <a:solidFill>
                   <a:srgbClr val="334155"/>
@@ -3450,6 +3480,7 @@
           <a:lstStyle xmlns:a="http://schemas.openxmlformats.org/drawingml/2006/main"/>
           <a:p xmlns:a="http://schemas.openxmlformats.org/drawingml/2006/main">
             <a:pPr algn="l">
+              <a:buNone/>
               <a:defRPr sz="1200" b="0">
                 <a:solidFill>
                   <a:srgbClr val="334155"/>
@@ -3506,6 +3537,7 @@
           <a:lstStyle xmlns:a="http://schemas.openxmlformats.org/drawingml/2006/main"/>
           <a:p xmlns:a="http://schemas.openxmlformats.org/drawingml/2006/main">
             <a:pPr algn="ctr">
+              <a:buNone/>
               <a:defRPr sz="1650" b="1">
                 <a:solidFill>
                   <a:srgbClr val="16A34A"/>
@@ -3591,6 +3623,7 @@
           <a:lstStyle xmlns:a="http://schemas.openxmlformats.org/drawingml/2006/main"/>
           <a:p xmlns:a="http://schemas.openxmlformats.org/drawingml/2006/main">
             <a:pPr algn="l">
+              <a:buNone/>
               <a:defRPr sz="1200" b="0">
                 <a:solidFill>
                   <a:srgbClr val="334155"/>
@@ -3676,6 +3709,7 @@
           <a:lstStyle xmlns:a="http://schemas.openxmlformats.org/drawingml/2006/main"/>
           <a:p xmlns:a="http://schemas.openxmlformats.org/drawingml/2006/main">
             <a:pPr algn="l">
+              <a:buNone/>
               <a:defRPr sz="1200" b="0">
                 <a:solidFill>
                   <a:srgbClr val="334155"/>
@@ -3761,6 +3795,7 @@
           <a:lstStyle xmlns:a="http://schemas.openxmlformats.org/drawingml/2006/main"/>
           <a:p xmlns:a="http://schemas.openxmlformats.org/drawingml/2006/main">
             <a:pPr algn="l">
+              <a:buNone/>
               <a:defRPr sz="1200" b="0">
                 <a:solidFill>
                   <a:srgbClr val="334155"/>
@@ -3846,6 +3881,7 @@
           <a:lstStyle xmlns:a="http://schemas.openxmlformats.org/drawingml/2006/main"/>
           <a:p xmlns:a="http://schemas.openxmlformats.org/drawingml/2006/main">
             <a:pPr algn="l">
+              <a:buNone/>
               <a:defRPr sz="1200" b="0">
                 <a:solidFill>
                   <a:srgbClr val="334155"/>
@@ -3902,6 +3938,7 @@
           <a:lstStyle xmlns:a="http://schemas.openxmlformats.org/drawingml/2006/main"/>
           <a:p xmlns:a="http://schemas.openxmlformats.org/drawingml/2006/main">
             <a:pPr algn="ctr">
+              <a:buNone/>
               <a:defRPr sz="1650" b="1">
                 <a:solidFill>
                   <a:srgbClr val="7C3AED"/>
@@ -3987,6 +4024,7 @@
           <a:lstStyle xmlns:a="http://schemas.openxmlformats.org/drawingml/2006/main"/>
           <a:p xmlns:a="http://schemas.openxmlformats.org/drawingml/2006/main">
             <a:pPr algn="l">
+              <a:buNone/>
               <a:defRPr sz="1200" b="0">
                 <a:solidFill>
                   <a:srgbClr val="334155"/>
@@ -4072,6 +4110,7 @@
           <a:lstStyle xmlns:a="http://schemas.openxmlformats.org/drawingml/2006/main"/>
           <a:p xmlns:a="http://schemas.openxmlformats.org/drawingml/2006/main">
             <a:pPr algn="l">
+              <a:buNone/>
               <a:defRPr sz="1200" b="0">
                 <a:solidFill>
                   <a:srgbClr val="334155"/>
@@ -4157,6 +4196,7 @@
           <a:lstStyle xmlns:a="http://schemas.openxmlformats.org/drawingml/2006/main"/>
           <a:p xmlns:a="http://schemas.openxmlformats.org/drawingml/2006/main">
             <a:pPr algn="l">
+              <a:buNone/>
               <a:defRPr sz="1200" b="0">
                 <a:solidFill>
                   <a:srgbClr val="334155"/>
@@ -4242,6 +4282,7 @@
           <a:lstStyle xmlns:a="http://schemas.openxmlformats.org/drawingml/2006/main"/>
           <a:p xmlns:a="http://schemas.openxmlformats.org/drawingml/2006/main">
             <a:pPr algn="l">
+              <a:buNone/>
               <a:defRPr sz="1200" b="0">
                 <a:solidFill>
                   <a:srgbClr val="334155"/>
@@ -4292,6 +4333,7 @@
           <a:lstStyle xmlns:a="http://schemas.openxmlformats.org/drawingml/2006/main"/>
           <a:p xmlns:a="http://schemas.openxmlformats.org/drawingml/2006/main">
             <a:pPr algn="l">
+              <a:buNone/>
               <a:defRPr sz="1500" b="1">
                 <a:solidFill>
                   <a:srgbClr val="111827"/>
@@ -4342,6 +4384,7 @@
           <a:lstStyle xmlns:a="http://schemas.openxmlformats.org/drawingml/2006/main"/>
           <a:p xmlns:a="http://schemas.openxmlformats.org/drawingml/2006/main">
             <a:pPr algn="l">
+              <a:buNone/>
               <a:defRPr sz="750" b="0">
                 <a:solidFill>
                   <a:srgbClr val="64748B"/>
@@ -4392,6 +4435,7 @@
           <a:lstStyle xmlns:a="http://schemas.openxmlformats.org/drawingml/2006/main"/>
           <a:p xmlns:a="http://schemas.openxmlformats.org/drawingml/2006/main">
             <a:pPr algn="r">
+              <a:buNone/>
               <a:defRPr sz="750" b="0">
                 <a:solidFill>
                   <a:srgbClr val="64748B"/>
@@ -4471,6 +4515,7 @@
           <a:lstStyle xmlns:a="http://schemas.openxmlformats.org/drawingml/2006/main"/>
           <a:p xmlns:a="http://schemas.openxmlformats.org/drawingml/2006/main">
             <a:pPr algn="l">
+              <a:buNone/>
               <a:defRPr sz="900" b="1">
                 <a:solidFill>
                   <a:srgbClr val="2563EB"/>
@@ -4521,6 +4566,7 @@
           <a:lstStyle xmlns:a="http://schemas.openxmlformats.org/drawingml/2006/main"/>
           <a:p xmlns:a="http://schemas.openxmlformats.org/drawingml/2006/main">
             <a:pPr algn="l">
+              <a:buNone/>
               <a:defRPr sz="2400" b="1">
                 <a:solidFill>
                   <a:srgbClr val="111827"/>
@@ -4577,6 +4623,7 @@
           <a:lstStyle xmlns:a="http://schemas.openxmlformats.org/drawingml/2006/main"/>
           <a:p xmlns:a="http://schemas.openxmlformats.org/drawingml/2006/main">
             <a:pPr algn="ctr">
+              <a:buNone/>
               <a:defRPr sz="900" b="1">
                 <a:solidFill>
                   <a:srgbClr val="16A34A"/>
@@ -4633,6 +4680,7 @@
           <a:lstStyle xmlns:a="http://schemas.openxmlformats.org/drawingml/2006/main"/>
           <a:p xmlns:a="http://schemas.openxmlformats.org/drawingml/2006/main">
             <a:pPr algn="ctr">
+              <a:buNone/>
               <a:defRPr sz="900" b="1">
                 <a:solidFill>
                   <a:srgbClr val="D97706"/>
@@ -4689,6 +4737,7 @@
           <a:lstStyle xmlns:a="http://schemas.openxmlformats.org/drawingml/2006/main"/>
           <a:p xmlns:a="http://schemas.openxmlformats.org/drawingml/2006/main">
             <a:pPr algn="ctr">
+              <a:buNone/>
               <a:defRPr sz="900" b="1">
                 <a:solidFill>
                   <a:srgbClr val="2563EB"/>
@@ -4745,6 +4794,7 @@
           <a:lstStyle xmlns:a="http://schemas.openxmlformats.org/drawingml/2006/main"/>
           <a:p xmlns:a="http://schemas.openxmlformats.org/drawingml/2006/main">
             <a:pPr algn="ctr">
+              <a:buNone/>
               <a:defRPr sz="1650" b="1">
                 <a:solidFill>
                   <a:srgbClr val="111827"/>
@@ -4830,6 +4880,7 @@
           <a:lstStyle xmlns:a="http://schemas.openxmlformats.org/drawingml/2006/main"/>
           <a:p xmlns:a="http://schemas.openxmlformats.org/drawingml/2006/main">
             <a:pPr algn="l">
+              <a:buNone/>
               <a:defRPr sz="1125" b="0">
                 <a:solidFill>
                   <a:srgbClr val="334155"/>
@@ -4915,6 +4966,7 @@
           <a:lstStyle xmlns:a="http://schemas.openxmlformats.org/drawingml/2006/main"/>
           <a:p xmlns:a="http://schemas.openxmlformats.org/drawingml/2006/main">
             <a:pPr algn="l">
+              <a:buNone/>
               <a:defRPr sz="1125" b="0">
                 <a:solidFill>
                   <a:srgbClr val="334155"/>
@@ -5000,6 +5052,7 @@
           <a:lstStyle xmlns:a="http://schemas.openxmlformats.org/drawingml/2006/main"/>
           <a:p xmlns:a="http://schemas.openxmlformats.org/drawingml/2006/main">
             <a:pPr algn="l">
+              <a:buNone/>
               <a:defRPr sz="1125" b="0">
                 <a:solidFill>
                   <a:srgbClr val="334155"/>
@@ -5085,6 +5138,7 @@
           <a:lstStyle xmlns:a="http://schemas.openxmlformats.org/drawingml/2006/main"/>
           <a:p xmlns:a="http://schemas.openxmlformats.org/drawingml/2006/main">
             <a:pPr algn="l">
+              <a:buNone/>
               <a:defRPr sz="1125" b="0">
                 <a:solidFill>
                   <a:srgbClr val="334155"/>
@@ -5141,6 +5195,7 @@
           <a:lstStyle xmlns:a="http://schemas.openxmlformats.org/drawingml/2006/main"/>
           <a:p xmlns:a="http://schemas.openxmlformats.org/drawingml/2006/main">
             <a:pPr algn="ctr">
+              <a:buNone/>
               <a:defRPr sz="1650" b="1">
                 <a:solidFill>
                   <a:srgbClr val="2563EB"/>
@@ -5230,6 +5285,7 @@
           <a:lstStyle xmlns:a="http://schemas.openxmlformats.org/drawingml/2006/main"/>
           <a:p xmlns:a="http://schemas.openxmlformats.org/drawingml/2006/main">
             <a:pPr algn="ctr">
+              <a:buNone/>
               <a:defRPr sz="1275" b="1">
                 <a:solidFill>
                   <a:srgbClr val="334155"/>
@@ -5252,6 +5308,7 @@
           </a:p>
           <a:p xmlns:a="http://schemas.openxmlformats.org/drawingml/2006/main">
             <a:pPr algn="ctr">
+              <a:buNone/>
               <a:defRPr sz="1275" b="1">
                 <a:solidFill>
                   <a:srgbClr val="334155"/>
@@ -5308,6 +5365,7 @@
           <a:lstStyle xmlns:a="http://schemas.openxmlformats.org/drawingml/2006/main"/>
           <a:p xmlns:a="http://schemas.openxmlformats.org/drawingml/2006/main">
             <a:pPr algn="ctr">
+              <a:buNone/>
               <a:defRPr sz="1650" b="1">
                 <a:solidFill>
                   <a:srgbClr val="16A34A"/>
@@ -5393,6 +5451,7 @@
           <a:lstStyle xmlns:a="http://schemas.openxmlformats.org/drawingml/2006/main"/>
           <a:p xmlns:a="http://schemas.openxmlformats.org/drawingml/2006/main">
             <a:pPr algn="l">
+              <a:buNone/>
               <a:defRPr sz="1200" b="0">
                 <a:solidFill>
                   <a:srgbClr val="334155"/>
@@ -5478,6 +5537,7 @@
           <a:lstStyle xmlns:a="http://schemas.openxmlformats.org/drawingml/2006/main"/>
           <a:p xmlns:a="http://schemas.openxmlformats.org/drawingml/2006/main">
             <a:pPr algn="l">
+              <a:buNone/>
               <a:defRPr sz="1200" b="0">
                 <a:solidFill>
                   <a:srgbClr val="334155"/>
@@ -5563,6 +5623,7 @@
           <a:lstStyle xmlns:a="http://schemas.openxmlformats.org/drawingml/2006/main"/>
           <a:p xmlns:a="http://schemas.openxmlformats.org/drawingml/2006/main">
             <a:pPr algn="l">
+              <a:buNone/>
               <a:defRPr sz="1200" b="0">
                 <a:solidFill>
                   <a:srgbClr val="334155"/>
@@ -5648,6 +5709,7 @@
           <a:lstStyle xmlns:a="http://schemas.openxmlformats.org/drawingml/2006/main"/>
           <a:p xmlns:a="http://schemas.openxmlformats.org/drawingml/2006/main">
             <a:pPr algn="l">
+              <a:buNone/>
               <a:defRPr sz="1200" b="0">
                 <a:solidFill>
                   <a:srgbClr val="334155"/>
@@ -5698,6 +5760,7 @@
           <a:lstStyle xmlns:a="http://schemas.openxmlformats.org/drawingml/2006/main"/>
           <a:p xmlns:a="http://schemas.openxmlformats.org/drawingml/2006/main">
             <a:pPr algn="l">
+              <a:buNone/>
               <a:defRPr sz="750" b="0">
                 <a:solidFill>
                   <a:srgbClr val="64748B"/>
@@ -5748,6 +5811,7 @@
           <a:lstStyle xmlns:a="http://schemas.openxmlformats.org/drawingml/2006/main"/>
           <a:p xmlns:a="http://schemas.openxmlformats.org/drawingml/2006/main">
             <a:pPr algn="r">
+              <a:buNone/>
               <a:defRPr sz="750" b="0">
                 <a:solidFill>
                   <a:srgbClr val="64748B"/>
@@ -5827,6 +5891,7 @@
           <a:lstStyle xmlns:a="http://schemas.openxmlformats.org/drawingml/2006/main"/>
           <a:p xmlns:a="http://schemas.openxmlformats.org/drawingml/2006/main">
             <a:pPr algn="l">
+              <a:buNone/>
               <a:defRPr sz="900" b="1">
                 <a:solidFill>
                   <a:srgbClr val="2563EB"/>
@@ -5877,6 +5942,7 @@
           <a:lstStyle xmlns:a="http://schemas.openxmlformats.org/drawingml/2006/main"/>
           <a:p xmlns:a="http://schemas.openxmlformats.org/drawingml/2006/main">
             <a:pPr algn="l">
+              <a:buNone/>
               <a:defRPr sz="2400" b="1">
                 <a:solidFill>
                   <a:srgbClr val="111827"/>
@@ -5933,6 +5999,7 @@
           <a:lstStyle xmlns:a="http://schemas.openxmlformats.org/drawingml/2006/main"/>
           <a:p xmlns:a="http://schemas.openxmlformats.org/drawingml/2006/main">
             <a:pPr algn="ctr">
+              <a:buNone/>
               <a:defRPr sz="1500" b="1">
                 <a:solidFill>
                   <a:srgbClr val="2563EB"/>
@@ -5989,6 +6056,7 @@
           <a:lstStyle xmlns:a="http://schemas.openxmlformats.org/drawingml/2006/main"/>
           <a:p xmlns:a="http://schemas.openxmlformats.org/drawingml/2006/main">
             <a:pPr algn="l">
+              <a:buNone/>
               <a:defRPr sz="1275" b="0">
                 <a:solidFill>
                   <a:srgbClr val="334155"/>
@@ -6045,6 +6113,7 @@
           <a:lstStyle xmlns:a="http://schemas.openxmlformats.org/drawingml/2006/main"/>
           <a:p xmlns:a="http://schemas.openxmlformats.org/drawingml/2006/main">
             <a:pPr algn="ctr">
+              <a:buNone/>
               <a:defRPr sz="1500" b="1">
                 <a:solidFill>
                   <a:srgbClr val="16A34A"/>
@@ -6101,6 +6170,7 @@
           <a:lstStyle xmlns:a="http://schemas.openxmlformats.org/drawingml/2006/main"/>
           <a:p xmlns:a="http://schemas.openxmlformats.org/drawingml/2006/main">
             <a:pPr algn="l">
+              <a:buNone/>
               <a:defRPr sz="1275" b="0">
                 <a:solidFill>
                   <a:srgbClr val="334155"/>
@@ -6157,6 +6227,7 @@
           <a:lstStyle xmlns:a="http://schemas.openxmlformats.org/drawingml/2006/main"/>
           <a:p xmlns:a="http://schemas.openxmlformats.org/drawingml/2006/main">
             <a:pPr algn="ctr">
+              <a:buNone/>
               <a:defRPr sz="1500" b="1">
                 <a:solidFill>
                   <a:srgbClr val="D97706"/>
@@ -6213,6 +6284,7 @@
           <a:lstStyle xmlns:a="http://schemas.openxmlformats.org/drawingml/2006/main"/>
           <a:p xmlns:a="http://schemas.openxmlformats.org/drawingml/2006/main">
             <a:pPr algn="l">
+              <a:buNone/>
               <a:defRPr sz="1275" b="0">
                 <a:solidFill>
                   <a:srgbClr val="334155"/>
@@ -6269,6 +6341,7 @@
           <a:lstStyle xmlns:a="http://schemas.openxmlformats.org/drawingml/2006/main"/>
           <a:p xmlns:a="http://schemas.openxmlformats.org/drawingml/2006/main">
             <a:pPr algn="ctr">
+              <a:buNone/>
               <a:defRPr sz="1500" b="1">
                 <a:solidFill>
                   <a:srgbClr val="2563EB"/>
@@ -6325,6 +6398,7 @@
           <a:lstStyle xmlns:a="http://schemas.openxmlformats.org/drawingml/2006/main"/>
           <a:p xmlns:a="http://schemas.openxmlformats.org/drawingml/2006/main">
             <a:pPr algn="l">
+              <a:buNone/>
               <a:defRPr sz="1275" b="0">
                 <a:solidFill>
                   <a:srgbClr val="334155"/>
@@ -6381,6 +6455,7 @@
           <a:lstStyle xmlns:a="http://schemas.openxmlformats.org/drawingml/2006/main"/>
           <a:p xmlns:a="http://schemas.openxmlformats.org/drawingml/2006/main">
             <a:pPr algn="ctr">
+              <a:buNone/>
               <a:defRPr sz="1500" b="1">
                 <a:solidFill>
                   <a:srgbClr val="16A34A"/>
@@ -6437,6 +6512,7 @@
           <a:lstStyle xmlns:a="http://schemas.openxmlformats.org/drawingml/2006/main"/>
           <a:p xmlns:a="http://schemas.openxmlformats.org/drawingml/2006/main">
             <a:pPr algn="l">
+              <a:buNone/>
               <a:defRPr sz="1275" b="0">
                 <a:solidFill>
                   <a:srgbClr val="334155"/>
@@ -6449,7 +6525,7 @@
                   <a:srgbClr val="334155"/>
                 </a:solidFill>
               </a:rPr>
-              <a:t>取指响应进入流水线</a:t>
+              <a:t>frontend 指令流进入流水线</a:t>
             </a:r>
           </a:p>
         </p:txBody>
@@ -6493,6 +6569,7 @@
           <a:lstStyle xmlns:a="http://schemas.openxmlformats.org/drawingml/2006/main"/>
           <a:p xmlns:a="http://schemas.openxmlformats.org/drawingml/2006/main">
             <a:pPr algn="ctr">
+              <a:buNone/>
               <a:defRPr sz="1500" b="1">
                 <a:solidFill>
                   <a:srgbClr val="D97706"/>
@@ -6549,6 +6626,7 @@
           <a:lstStyle xmlns:a="http://schemas.openxmlformats.org/drawingml/2006/main"/>
           <a:p xmlns:a="http://schemas.openxmlformats.org/drawingml/2006/main">
             <a:pPr algn="l">
+              <a:buNone/>
               <a:defRPr sz="1275" b="0">
                 <a:solidFill>
                   <a:srgbClr val="334155"/>
@@ -6605,6 +6683,7 @@
           <a:lstStyle xmlns:a="http://schemas.openxmlformats.org/drawingml/2006/main"/>
           <a:p xmlns:a="http://schemas.openxmlformats.org/drawingml/2006/main">
             <a:pPr algn="ctr">
+              <a:buNone/>
               <a:defRPr sz="1125" b="1">
                 <a:solidFill>
                   <a:srgbClr val="7C3AED"/>
@@ -6622,6 +6701,7 @@
           </a:p>
           <a:p xmlns:a="http://schemas.openxmlformats.org/drawingml/2006/main">
             <a:pPr algn="ctr">
+              <a:buNone/>
               <a:defRPr sz="1125" b="1">
                 <a:solidFill>
                   <a:srgbClr val="7C3AED"/>
@@ -6672,6 +6752,7 @@
           <a:lstStyle xmlns:a="http://schemas.openxmlformats.org/drawingml/2006/main"/>
           <a:p xmlns:a="http://schemas.openxmlformats.org/drawingml/2006/main">
             <a:pPr algn="l">
+              <a:buNone/>
               <a:defRPr sz="750" b="0">
                 <a:solidFill>
                   <a:srgbClr val="64748B"/>
@@ -6722,6 +6803,7 @@
           <a:lstStyle xmlns:a="http://schemas.openxmlformats.org/drawingml/2006/main"/>
           <a:p xmlns:a="http://schemas.openxmlformats.org/drawingml/2006/main">
             <a:pPr algn="r">
+              <a:buNone/>
               <a:defRPr sz="750" b="0">
                 <a:solidFill>
                   <a:srgbClr val="64748B"/>
@@ -6801,6 +6883,7 @@
           <a:lstStyle xmlns:a="http://schemas.openxmlformats.org/drawingml/2006/main"/>
           <a:p xmlns:a="http://schemas.openxmlformats.org/drawingml/2006/main">
             <a:pPr algn="l">
+              <a:buNone/>
               <a:defRPr sz="900" b="1">
                 <a:solidFill>
                   <a:srgbClr val="2563EB"/>
@@ -6851,6 +6934,7 @@
           <a:lstStyle xmlns:a="http://schemas.openxmlformats.org/drawingml/2006/main"/>
           <a:p xmlns:a="http://schemas.openxmlformats.org/drawingml/2006/main">
             <a:pPr algn="l">
+              <a:buNone/>
               <a:defRPr sz="2400" b="1">
                 <a:solidFill>
                   <a:srgbClr val="111827"/>
@@ -6907,6 +6991,7 @@
           <a:lstStyle xmlns:a="http://schemas.openxmlformats.org/drawingml/2006/main"/>
           <a:p xmlns:a="http://schemas.openxmlformats.org/drawingml/2006/main">
             <a:pPr algn="ctr">
+              <a:buNone/>
               <a:defRPr sz="900" b="1">
                 <a:solidFill>
                   <a:srgbClr val="16A34A"/>
@@ -6963,6 +7048,7 @@
           <a:lstStyle xmlns:a="http://schemas.openxmlformats.org/drawingml/2006/main"/>
           <a:p xmlns:a="http://schemas.openxmlformats.org/drawingml/2006/main">
             <a:pPr algn="ctr">
+              <a:buNone/>
               <a:defRPr sz="900" b="1">
                 <a:solidFill>
                   <a:srgbClr val="D97706"/>
@@ -7019,6 +7105,7 @@
           <a:lstStyle xmlns:a="http://schemas.openxmlformats.org/drawingml/2006/main"/>
           <a:p xmlns:a="http://schemas.openxmlformats.org/drawingml/2006/main">
             <a:pPr algn="ctr">
+              <a:buNone/>
               <a:defRPr sz="900" b="1">
                 <a:solidFill>
                   <a:srgbClr val="2563EB"/>
@@ -7075,6 +7162,7 @@
           <a:lstStyle xmlns:a="http://schemas.openxmlformats.org/drawingml/2006/main"/>
           <a:p xmlns:a="http://schemas.openxmlformats.org/drawingml/2006/main">
             <a:pPr algn="ctr">
+              <a:buNone/>
               <a:defRPr sz="1050" b="1">
                 <a:solidFill>
                   <a:srgbClr val="2563EB"/>
@@ -7087,11 +7175,12 @@
                   <a:srgbClr val="2563EB"/>
                 </a:solidFill>
               </a:rPr>
-              <a:t>if req/rsp</a:t>
+              <a:t>frontend instr</a:t>
             </a:r>
           </a:p>
           <a:p xmlns:a="http://schemas.openxmlformats.org/drawingml/2006/main">
             <a:pPr algn="ctr">
+              <a:buNone/>
               <a:defRPr sz="1050" b="1">
                 <a:solidFill>
                   <a:srgbClr val="2563EB"/>
@@ -7104,7 +7193,7 @@
                   <a:srgbClr val="2563EB"/>
                 </a:solidFill>
               </a:rPr>
-              <a:t>IF</a:t>
+              <a:t>IF stream</a:t>
             </a:r>
           </a:p>
         </p:txBody>
@@ -7148,6 +7237,7 @@
           <a:lstStyle xmlns:a="http://schemas.openxmlformats.org/drawingml/2006/main"/>
           <a:p xmlns:a="http://schemas.openxmlformats.org/drawingml/2006/main">
             <a:pPr algn="ctr">
+              <a:buNone/>
               <a:defRPr sz="1050" b="1">
                 <a:solidFill>
                   <a:srgbClr val="16A34A"/>
@@ -7165,6 +7255,7 @@
           </a:p>
           <a:p xmlns:a="http://schemas.openxmlformats.org/drawingml/2006/main">
             <a:pPr algn="ctr">
+              <a:buNone/>
               <a:defRPr sz="1050" b="1">
                 <a:solidFill>
                   <a:srgbClr val="16A34A"/>
@@ -7221,6 +7312,7 @@
           <a:lstStyle xmlns:a="http://schemas.openxmlformats.org/drawingml/2006/main"/>
           <a:p xmlns:a="http://schemas.openxmlformats.org/drawingml/2006/main">
             <a:pPr algn="ctr">
+              <a:buNone/>
               <a:defRPr sz="1050" b="1">
                 <a:solidFill>
                   <a:srgbClr val="D97706"/>
@@ -7233,11 +7325,12 @@
                   <a:srgbClr val="D97706"/>
                 </a:solidFill>
               </a:rPr>
-              <a:t>decode/ALU/branch</a:t>
+              <a:t>decode/ALU/BR</a:t>
             </a:r>
           </a:p>
           <a:p xmlns:a="http://schemas.openxmlformats.org/drawingml/2006/main">
             <a:pPr algn="ctr">
+              <a:buNone/>
               <a:defRPr sz="1050" b="1">
                 <a:solidFill>
                   <a:srgbClr val="D97706"/>
@@ -7294,6 +7387,7 @@
           <a:lstStyle xmlns:a="http://schemas.openxmlformats.org/drawingml/2006/main"/>
           <a:p xmlns:a="http://schemas.openxmlformats.org/drawingml/2006/main">
             <a:pPr algn="ctr">
+              <a:buNone/>
               <a:defRPr sz="1050" b="1">
                 <a:solidFill>
                   <a:srgbClr val="16A34A"/>
@@ -7311,6 +7405,7 @@
           </a:p>
           <a:p xmlns:a="http://schemas.openxmlformats.org/drawingml/2006/main">
             <a:pPr algn="ctr">
+              <a:buNone/>
               <a:defRPr sz="1050" b="1">
                 <a:solidFill>
                   <a:srgbClr val="16A34A"/>
@@ -7367,6 +7462,7 @@
           <a:lstStyle xmlns:a="http://schemas.openxmlformats.org/drawingml/2006/main"/>
           <a:p xmlns:a="http://schemas.openxmlformats.org/drawingml/2006/main">
             <a:pPr algn="ctr">
+              <a:buNone/>
               <a:defRPr sz="1050" b="1">
                 <a:solidFill>
                   <a:srgbClr val="16A34A"/>
@@ -7384,6 +7480,7 @@
           </a:p>
           <a:p xmlns:a="http://schemas.openxmlformats.org/drawingml/2006/main">
             <a:pPr algn="ctr">
+              <a:buNone/>
               <a:defRPr sz="1050" b="1">
                 <a:solidFill>
                   <a:srgbClr val="16A34A"/>
@@ -7440,6 +7537,7 @@
           <a:lstStyle xmlns:a="http://schemas.openxmlformats.org/drawingml/2006/main"/>
           <a:p xmlns:a="http://schemas.openxmlformats.org/drawingml/2006/main">
             <a:pPr algn="ctr">
+              <a:buNone/>
               <a:defRPr sz="1050" b="1">
                 <a:solidFill>
                   <a:srgbClr val="2563EB"/>
@@ -7457,6 +7555,7 @@
           </a:p>
           <a:p xmlns:a="http://schemas.openxmlformats.org/drawingml/2006/main">
             <a:pPr algn="ctr">
+              <a:buNone/>
               <a:defRPr sz="1050" b="1">
                 <a:solidFill>
                   <a:srgbClr val="2563EB"/>
@@ -7469,7 +7568,7 @@
                   <a:srgbClr val="2563EB"/>
                 </a:solidFill>
               </a:rPr>
-              <a:t>IF req/rsp</a:t>
+              <a:t>IF staged</a:t>
             </a:r>
           </a:p>
         </p:txBody>
@@ -7513,6 +7612,7 @@
           <a:lstStyle xmlns:a="http://schemas.openxmlformats.org/drawingml/2006/main"/>
           <a:p xmlns:a="http://schemas.openxmlformats.org/drawingml/2006/main">
             <a:pPr algn="ctr">
+              <a:buNone/>
               <a:defRPr sz="1050" b="1">
                 <a:solidFill>
                   <a:srgbClr val="2563EB"/>
@@ -7525,11 +7625,12 @@
                   <a:srgbClr val="2563EB"/>
                 </a:solidFill>
               </a:rPr>
-              <a:t>commit/debug hooks</a:t>
+              <a:t>commit/debug</a:t>
             </a:r>
           </a:p>
           <a:p xmlns:a="http://schemas.openxmlformats.org/drawingml/2006/main">
             <a:pPr algn="ctr">
+              <a:buNone/>
               <a:defRPr sz="1050" b="1">
                 <a:solidFill>
                   <a:srgbClr val="2563EB"/>
@@ -7580,6 +7681,7 @@
           <a:lstStyle xmlns:a="http://schemas.openxmlformats.org/drawingml/2006/main"/>
           <a:p xmlns:a="http://schemas.openxmlformats.org/drawingml/2006/main">
             <a:pPr algn="l">
+              <a:buNone/>
               <a:defRPr sz="1500" b="1">
                 <a:solidFill>
                   <a:srgbClr val="111827"/>
@@ -7665,6 +7767,7 @@
           <a:lstStyle xmlns:a="http://schemas.openxmlformats.org/drawingml/2006/main"/>
           <a:p xmlns:a="http://schemas.openxmlformats.org/drawingml/2006/main">
             <a:pPr algn="l">
+              <a:buNone/>
               <a:defRPr sz="1200" b="0">
                 <a:solidFill>
                   <a:srgbClr val="334155"/>
@@ -7750,6 +7853,7 @@
           <a:lstStyle xmlns:a="http://schemas.openxmlformats.org/drawingml/2006/main"/>
           <a:p xmlns:a="http://schemas.openxmlformats.org/drawingml/2006/main">
             <a:pPr algn="l">
+              <a:buNone/>
               <a:defRPr sz="1200" b="0">
                 <a:solidFill>
                   <a:srgbClr val="334155"/>
@@ -7835,6 +7939,7 @@
           <a:lstStyle xmlns:a="http://schemas.openxmlformats.org/drawingml/2006/main"/>
           <a:p xmlns:a="http://schemas.openxmlformats.org/drawingml/2006/main">
             <a:pPr algn="l">
+              <a:buNone/>
               <a:defRPr sz="1200" b="0">
                 <a:solidFill>
                   <a:srgbClr val="334155"/>
@@ -7920,6 +8025,7 @@
           <a:lstStyle xmlns:a="http://schemas.openxmlformats.org/drawingml/2006/main"/>
           <a:p xmlns:a="http://schemas.openxmlformats.org/drawingml/2006/main">
             <a:pPr algn="l">
+              <a:buNone/>
               <a:defRPr sz="1200" b="0">
                 <a:solidFill>
                   <a:srgbClr val="334155"/>
@@ -7970,6 +8076,7 @@
           <a:lstStyle xmlns:a="http://schemas.openxmlformats.org/drawingml/2006/main"/>
           <a:p xmlns:a="http://schemas.openxmlformats.org/drawingml/2006/main">
             <a:pPr algn="l">
+              <a:buNone/>
               <a:defRPr sz="750" b="0">
                 <a:solidFill>
                   <a:srgbClr val="64748B"/>
@@ -8020,6 +8127,7 @@
           <a:lstStyle xmlns:a="http://schemas.openxmlformats.org/drawingml/2006/main"/>
           <a:p xmlns:a="http://schemas.openxmlformats.org/drawingml/2006/main">
             <a:pPr algn="r">
+              <a:buNone/>
               <a:defRPr sz="750" b="0">
                 <a:solidFill>
                   <a:srgbClr val="64748B"/>
@@ -8099,6 +8207,7 @@
           <a:lstStyle xmlns:a="http://schemas.openxmlformats.org/drawingml/2006/main"/>
           <a:p xmlns:a="http://schemas.openxmlformats.org/drawingml/2006/main">
             <a:pPr algn="l">
+              <a:buNone/>
               <a:defRPr sz="900" b="1">
                 <a:solidFill>
                   <a:srgbClr val="2563EB"/>
@@ -8149,6 +8258,7 @@
           <a:lstStyle xmlns:a="http://schemas.openxmlformats.org/drawingml/2006/main"/>
           <a:p xmlns:a="http://schemas.openxmlformats.org/drawingml/2006/main">
             <a:pPr algn="l">
+              <a:buNone/>
               <a:defRPr sz="2400" b="1">
                 <a:solidFill>
                   <a:srgbClr val="111827"/>
@@ -8205,6 +8315,7 @@
           <a:lstStyle xmlns:a="http://schemas.openxmlformats.org/drawingml/2006/main"/>
           <a:p xmlns:a="http://schemas.openxmlformats.org/drawingml/2006/main">
             <a:pPr algn="ctr">
+              <a:buNone/>
               <a:defRPr sz="975" b="1">
                 <a:solidFill>
                   <a:srgbClr val="2563EB"/>
@@ -8217,7 +8328,7 @@
                   <a:srgbClr val="2563EB"/>
                 </a:solidFill>
               </a:rPr>
-              <a:t>取指响应进入流水线</a:t>
+              <a:t>frontend 指令流进入流水线</a:t>
             </a:r>
           </a:p>
         </p:txBody>
@@ -8294,6 +8405,7 @@
           <a:lstStyle xmlns:a="http://schemas.openxmlformats.org/drawingml/2006/main"/>
           <a:p xmlns:a="http://schemas.openxmlformats.org/drawingml/2006/main">
             <a:pPr algn="ctr">
+              <a:buNone/>
               <a:defRPr sz="975" b="1">
                 <a:solidFill>
                   <a:srgbClr val="16A34A"/>
@@ -8383,6 +8495,7 @@
           <a:lstStyle xmlns:a="http://schemas.openxmlformats.org/drawingml/2006/main"/>
           <a:p xmlns:a="http://schemas.openxmlformats.org/drawingml/2006/main">
             <a:pPr algn="ctr">
+              <a:buNone/>
               <a:defRPr sz="975" b="1">
                 <a:solidFill>
                   <a:srgbClr val="2563EB"/>
@@ -8472,6 +8585,7 @@
           <a:lstStyle xmlns:a="http://schemas.openxmlformats.org/drawingml/2006/main"/>
           <a:p xmlns:a="http://schemas.openxmlformats.org/drawingml/2006/main">
             <a:pPr algn="ctr">
+              <a:buNone/>
               <a:defRPr sz="975" b="1">
                 <a:solidFill>
                   <a:srgbClr val="16A34A"/>
@@ -8528,6 +8642,7 @@
           <a:lstStyle xmlns:a="http://schemas.openxmlformats.org/drawingml/2006/main"/>
           <a:p xmlns:a="http://schemas.openxmlformats.org/drawingml/2006/main">
             <a:pPr algn="ctr">
+              <a:buNone/>
               <a:defRPr sz="1500" b="1">
                 <a:solidFill>
                   <a:srgbClr val="111827"/>
@@ -8613,6 +8728,7 @@
           <a:lstStyle xmlns:a="http://schemas.openxmlformats.org/drawingml/2006/main"/>
           <a:p xmlns:a="http://schemas.openxmlformats.org/drawingml/2006/main">
             <a:pPr algn="l">
+              <a:buNone/>
               <a:defRPr sz="1200" b="0">
                 <a:solidFill>
                   <a:srgbClr val="334155"/>
@@ -8625,7 +8741,7 @@
                   <a:srgbClr val="334155"/>
                 </a:solidFill>
               </a:rPr>
-              <a:t>取指响应进入流水线</a:t>
+              <a:t>frontend 指令流进入流水线</a:t>
             </a:r>
           </a:p>
         </p:txBody>
@@ -8698,6 +8814,7 @@
           <a:lstStyle xmlns:a="http://schemas.openxmlformats.org/drawingml/2006/main"/>
           <a:p xmlns:a="http://schemas.openxmlformats.org/drawingml/2006/main">
             <a:pPr algn="l">
+              <a:buNone/>
               <a:defRPr sz="1200" b="0">
                 <a:solidFill>
                   <a:srgbClr val="334155"/>
@@ -8783,6 +8900,7 @@
           <a:lstStyle xmlns:a="http://schemas.openxmlformats.org/drawingml/2006/main"/>
           <a:p xmlns:a="http://schemas.openxmlformats.org/drawingml/2006/main">
             <a:pPr algn="l">
+              <a:buNone/>
               <a:defRPr sz="1200" b="0">
                 <a:solidFill>
                   <a:srgbClr val="334155"/>
@@ -8868,6 +8986,7 @@
           <a:lstStyle xmlns:a="http://schemas.openxmlformats.org/drawingml/2006/main"/>
           <a:p xmlns:a="http://schemas.openxmlformats.org/drawingml/2006/main">
             <a:pPr algn="l">
+              <a:buNone/>
               <a:defRPr sz="1200" b="0">
                 <a:solidFill>
                   <a:srgbClr val="334155"/>
@@ -8918,6 +9037,7 @@
           <a:lstStyle xmlns:a="http://schemas.openxmlformats.org/drawingml/2006/main"/>
           <a:p xmlns:a="http://schemas.openxmlformats.org/drawingml/2006/main">
             <a:pPr algn="l">
+              <a:buNone/>
               <a:defRPr sz="750" b="0">
                 <a:solidFill>
                   <a:srgbClr val="64748B"/>
@@ -8968,6 +9088,7 @@
           <a:lstStyle xmlns:a="http://schemas.openxmlformats.org/drawingml/2006/main"/>
           <a:p xmlns:a="http://schemas.openxmlformats.org/drawingml/2006/main">
             <a:pPr algn="r">
+              <a:buNone/>
               <a:defRPr sz="750" b="0">
                 <a:solidFill>
                   <a:srgbClr val="64748B"/>
@@ -9047,6 +9168,7 @@
           <a:lstStyle xmlns:a="http://schemas.openxmlformats.org/drawingml/2006/main"/>
           <a:p xmlns:a="http://schemas.openxmlformats.org/drawingml/2006/main">
             <a:pPr algn="l">
+              <a:buNone/>
               <a:defRPr sz="900" b="1">
                 <a:solidFill>
                   <a:srgbClr val="2563EB"/>
@@ -9097,6 +9219,7 @@
           <a:lstStyle xmlns:a="http://schemas.openxmlformats.org/drawingml/2006/main"/>
           <a:p xmlns:a="http://schemas.openxmlformats.org/drawingml/2006/main">
             <a:pPr algn="l">
+              <a:buNone/>
               <a:defRPr sz="2400" b="1">
                 <a:solidFill>
                   <a:srgbClr val="111827"/>
@@ -9116,14 +9239,14 @@
       </p:sp>
       <p:pic>
         <p:nvPicPr>
-          <p:cNvPr id="17" name=""/>
+          <p:cNvPr id="21" name=""/>
           <p:cNvPicPr>
             <a:picLocks xmlns:a="http://schemas.openxmlformats.org/drawingml/2006/main" noChangeAspect="1"/>
           </p:cNvPicPr>
           <p:nvPr/>
         </p:nvPicPr>
         <p:blipFill>
-          <a:blip xmlns:r="http://schemas.openxmlformats.org/officeDocument/2006/relationships" xmlns:a="http://schemas.openxmlformats.org/drawingml/2006/main" r:embed="R3f773805226c4be5"/>
+          <a:blip xmlns:r="http://schemas.openxmlformats.org/officeDocument/2006/relationships" xmlns:a="http://schemas.openxmlformats.org/drawingml/2006/main" r:embed="R8a222234773e4f7d"/>
           <a:stretch xmlns:a="http://schemas.openxmlformats.org/drawingml/2006/main"/>
         </p:blipFill>
         <p:spPr>
@@ -9138,14 +9261,14 @@
       </p:pic>
       <p:pic>
         <p:nvPicPr>
-          <p:cNvPr id="18" name=""/>
+          <p:cNvPr id="22" name=""/>
           <p:cNvPicPr>
             <a:picLocks xmlns:a="http://schemas.openxmlformats.org/drawingml/2006/main" noChangeAspect="1"/>
           </p:cNvPicPr>
           <p:nvPr/>
         </p:nvPicPr>
         <p:blipFill>
-          <a:blip xmlns:r="http://schemas.openxmlformats.org/officeDocument/2006/relationships" xmlns:a="http://schemas.openxmlformats.org/drawingml/2006/main" r:embed="R1d8eecc445924f61"/>
+          <a:blip xmlns:r="http://schemas.openxmlformats.org/officeDocument/2006/relationships" xmlns:a="http://schemas.openxmlformats.org/drawingml/2006/main" r:embed="Rc6bdd8839a9f426f"/>
           <a:stretch xmlns:a="http://schemas.openxmlformats.org/drawingml/2006/main"/>
         </p:blipFill>
         <p:spPr>
@@ -9160,14 +9283,14 @@
       </p:pic>
       <p:pic>
         <p:nvPicPr>
-          <p:cNvPr id="19" name=""/>
+          <p:cNvPr id="23" name=""/>
           <p:cNvPicPr>
             <a:picLocks xmlns:a="http://schemas.openxmlformats.org/drawingml/2006/main" noChangeAspect="1"/>
           </p:cNvPicPr>
           <p:nvPr/>
         </p:nvPicPr>
         <p:blipFill>
-          <a:blip xmlns:r="http://schemas.openxmlformats.org/officeDocument/2006/relationships" xmlns:a="http://schemas.openxmlformats.org/drawingml/2006/main" r:embed="Rd84e2f635d4e4bc6"/>
+          <a:blip xmlns:r="http://schemas.openxmlformats.org/officeDocument/2006/relationships" xmlns:a="http://schemas.openxmlformats.org/drawingml/2006/main" r:embed="Rca2168bfe37d4201"/>
           <a:stretch xmlns:a="http://schemas.openxmlformats.org/drawingml/2006/main"/>
         </p:blipFill>
         <p:spPr>
@@ -9182,14 +9305,14 @@
       </p:pic>
       <p:pic>
         <p:nvPicPr>
-          <p:cNvPr id="20" name=""/>
+          <p:cNvPr id="24" name=""/>
           <p:cNvPicPr>
             <a:picLocks xmlns:a="http://schemas.openxmlformats.org/drawingml/2006/main" noChangeAspect="1"/>
           </p:cNvPicPr>
           <p:nvPr/>
         </p:nvPicPr>
         <p:blipFill>
-          <a:blip xmlns:r="http://schemas.openxmlformats.org/officeDocument/2006/relationships" xmlns:a="http://schemas.openxmlformats.org/drawingml/2006/main" r:embed="Rafbc89fdba5d423f"/>
+          <a:blip xmlns:r="http://schemas.openxmlformats.org/officeDocument/2006/relationships" xmlns:a="http://schemas.openxmlformats.org/drawingml/2006/main" r:embed="R83a1ec87f46341e4"/>
           <a:stretch xmlns:a="http://schemas.openxmlformats.org/drawingml/2006/main"/>
         </p:blipFill>
         <p:spPr>
@@ -9270,6 +9393,7 @@
           <a:lstStyle xmlns:a="http://schemas.openxmlformats.org/drawingml/2006/main"/>
           <a:p xmlns:a="http://schemas.openxmlformats.org/drawingml/2006/main">
             <a:pPr algn="l">
+              <a:buNone/>
               <a:defRPr sz="1200" b="0">
                 <a:solidFill>
                   <a:srgbClr val="334155"/>
@@ -9355,6 +9479,7 @@
           <a:lstStyle xmlns:a="http://schemas.openxmlformats.org/drawingml/2006/main"/>
           <a:p xmlns:a="http://schemas.openxmlformats.org/drawingml/2006/main">
             <a:pPr algn="l">
+              <a:buNone/>
               <a:defRPr sz="1200" b="0">
                 <a:solidFill>
                   <a:srgbClr val="334155"/>
@@ -9440,6 +9565,7 @@
           <a:lstStyle xmlns:a="http://schemas.openxmlformats.org/drawingml/2006/main"/>
           <a:p xmlns:a="http://schemas.openxmlformats.org/drawingml/2006/main">
             <a:pPr algn="l">
+              <a:buNone/>
               <a:defRPr sz="1200" b="0">
                 <a:solidFill>
                   <a:srgbClr val="334155"/>
@@ -9490,6 +9616,7 @@
           <a:lstStyle xmlns:a="http://schemas.openxmlformats.org/drawingml/2006/main"/>
           <a:p xmlns:a="http://schemas.openxmlformats.org/drawingml/2006/main">
             <a:pPr algn="l">
+              <a:buNone/>
               <a:defRPr sz="750" b="0">
                 <a:solidFill>
                   <a:srgbClr val="64748B"/>
@@ -9540,6 +9667,7 @@
           <a:lstStyle xmlns:a="http://schemas.openxmlformats.org/drawingml/2006/main"/>
           <a:p xmlns:a="http://schemas.openxmlformats.org/drawingml/2006/main">
             <a:pPr algn="r">
+              <a:buNone/>
               <a:defRPr sz="750" b="0">
                 <a:solidFill>
                   <a:srgbClr val="64748B"/>
@@ -9619,6 +9747,7 @@
           <a:lstStyle xmlns:a="http://schemas.openxmlformats.org/drawingml/2006/main"/>
           <a:p xmlns:a="http://schemas.openxmlformats.org/drawingml/2006/main">
             <a:pPr algn="l">
+              <a:buNone/>
               <a:defRPr sz="900" b="1">
                 <a:solidFill>
                   <a:srgbClr val="2563EB"/>
@@ -9669,6 +9798,7 @@
           <a:lstStyle xmlns:a="http://schemas.openxmlformats.org/drawingml/2006/main"/>
           <a:p xmlns:a="http://schemas.openxmlformats.org/drawingml/2006/main">
             <a:pPr algn="l">
+              <a:buNone/>
               <a:defRPr sz="2400" b="1">
                 <a:solidFill>
                   <a:srgbClr val="111827"/>
@@ -9725,6 +9855,7 @@
           <a:lstStyle xmlns:a="http://schemas.openxmlformats.org/drawingml/2006/main"/>
           <a:p xmlns:a="http://schemas.openxmlformats.org/drawingml/2006/main">
             <a:pPr algn="ctr">
+              <a:buNone/>
               <a:defRPr sz="1650" b="1">
                 <a:solidFill>
                   <a:srgbClr val="16A34A"/>
@@ -9781,6 +9912,7 @@
           <a:lstStyle xmlns:a="http://schemas.openxmlformats.org/drawingml/2006/main"/>
           <a:p xmlns:a="http://schemas.openxmlformats.org/drawingml/2006/main">
             <a:pPr algn="ctr">
+              <a:buNone/>
               <a:defRPr sz="1650" b="1">
                 <a:solidFill>
                   <a:srgbClr val="2563EB"/>
@@ -9837,6 +9969,7 @@
           <a:lstStyle xmlns:a="http://schemas.openxmlformats.org/drawingml/2006/main"/>
           <a:p xmlns:a="http://schemas.openxmlformats.org/drawingml/2006/main">
             <a:pPr algn="ctr">
+              <a:buNone/>
               <a:defRPr sz="1650" b="1">
                 <a:solidFill>
                   <a:srgbClr val="DC2626"/>
@@ -9893,6 +10026,7 @@
           <a:lstStyle xmlns:a="http://schemas.openxmlformats.org/drawingml/2006/main"/>
           <a:p xmlns:a="http://schemas.openxmlformats.org/drawingml/2006/main">
             <a:pPr algn="ctr">
+              <a:buNone/>
               <a:defRPr sz="1650" b="1">
                 <a:solidFill>
                   <a:srgbClr val="D97706"/>
@@ -9949,6 +10083,7 @@
           <a:lstStyle xmlns:a="http://schemas.openxmlformats.org/drawingml/2006/main"/>
           <a:p xmlns:a="http://schemas.openxmlformats.org/drawingml/2006/main">
             <a:pPr algn="ctr">
+              <a:buNone/>
               <a:defRPr sz="1200" b="0">
                 <a:solidFill>
                   <a:srgbClr val="334155"/>
@@ -10038,6 +10173,7 @@
           <a:lstStyle xmlns:a="http://schemas.openxmlformats.org/drawingml/2006/main"/>
           <a:p xmlns:a="http://schemas.openxmlformats.org/drawingml/2006/main">
             <a:pPr algn="ctr">
+              <a:buNone/>
               <a:defRPr sz="1200" b="0">
                 <a:solidFill>
                   <a:srgbClr val="334155"/>
@@ -10127,6 +10263,7 @@
           <a:lstStyle xmlns:a="http://schemas.openxmlformats.org/drawingml/2006/main"/>
           <a:p xmlns:a="http://schemas.openxmlformats.org/drawingml/2006/main">
             <a:pPr algn="ctr">
+              <a:buNone/>
               <a:defRPr sz="1200" b="0">
                 <a:solidFill>
                   <a:srgbClr val="334155"/>
@@ -10216,6 +10353,7 @@
           <a:lstStyle xmlns:a="http://schemas.openxmlformats.org/drawingml/2006/main"/>
           <a:p xmlns:a="http://schemas.openxmlformats.org/drawingml/2006/main">
             <a:pPr algn="ctr">
+              <a:buNone/>
               <a:defRPr sz="1200" b="0">
                 <a:solidFill>
                   <a:srgbClr val="334155"/>
@@ -10305,6 +10443,7 @@
           <a:lstStyle xmlns:a="http://schemas.openxmlformats.org/drawingml/2006/main"/>
           <a:p xmlns:a="http://schemas.openxmlformats.org/drawingml/2006/main">
             <a:pPr algn="ctr">
+              <a:buNone/>
               <a:defRPr sz="1725" b="1">
                 <a:solidFill>
                   <a:srgbClr val="7C3AED"/>
@@ -10355,6 +10494,7 @@
           <a:lstStyle xmlns:a="http://schemas.openxmlformats.org/drawingml/2006/main"/>
           <a:p xmlns:a="http://schemas.openxmlformats.org/drawingml/2006/main">
             <a:pPr algn="l">
+              <a:buNone/>
               <a:defRPr sz="750" b="0">
                 <a:solidFill>
                   <a:srgbClr val="64748B"/>
@@ -10405,6 +10545,7 @@
           <a:lstStyle xmlns:a="http://schemas.openxmlformats.org/drawingml/2006/main"/>
           <a:p xmlns:a="http://schemas.openxmlformats.org/drawingml/2006/main">
             <a:pPr algn="r">
+              <a:buNone/>
               <a:defRPr sz="750" b="0">
                 <a:solidFill>
                   <a:srgbClr val="64748B"/>
@@ -10484,6 +10625,7 @@
           <a:lstStyle xmlns:a="http://schemas.openxmlformats.org/drawingml/2006/main"/>
           <a:p xmlns:a="http://schemas.openxmlformats.org/drawingml/2006/main">
             <a:pPr algn="l">
+              <a:buNone/>
               <a:defRPr sz="900" b="1">
                 <a:solidFill>
                   <a:srgbClr val="2563EB"/>
@@ -10534,6 +10676,7 @@
           <a:lstStyle xmlns:a="http://schemas.openxmlformats.org/drawingml/2006/main"/>
           <a:p xmlns:a="http://schemas.openxmlformats.org/drawingml/2006/main">
             <a:pPr algn="l">
+              <a:buNone/>
               <a:defRPr sz="2400" b="1">
                 <a:solidFill>
                   <a:srgbClr val="111827"/>
@@ -10590,6 +10733,7 @@
           <a:lstStyle xmlns:a="http://schemas.openxmlformats.org/drawingml/2006/main"/>
           <a:p xmlns:a="http://schemas.openxmlformats.org/drawingml/2006/main">
             <a:pPr algn="ctr">
+              <a:buNone/>
               <a:defRPr sz="975" b="1">
                 <a:solidFill>
                   <a:srgbClr val="2563EB"/>
@@ -10646,6 +10790,7 @@
           <a:lstStyle xmlns:a="http://schemas.openxmlformats.org/drawingml/2006/main"/>
           <a:p xmlns:a="http://schemas.openxmlformats.org/drawingml/2006/main">
             <a:pPr algn="ctr">
+              <a:buNone/>
               <a:defRPr sz="975" b="1">
                 <a:solidFill>
                   <a:srgbClr val="2563EB"/>
@@ -10702,6 +10847,7 @@
           <a:lstStyle xmlns:a="http://schemas.openxmlformats.org/drawingml/2006/main"/>
           <a:p xmlns:a="http://schemas.openxmlformats.org/drawingml/2006/main">
             <a:pPr algn="ctr">
+              <a:buNone/>
               <a:defRPr sz="975" b="1">
                 <a:solidFill>
                   <a:srgbClr val="2563EB"/>
@@ -10758,6 +10904,7 @@
           <a:lstStyle xmlns:a="http://schemas.openxmlformats.org/drawingml/2006/main"/>
           <a:p xmlns:a="http://schemas.openxmlformats.org/drawingml/2006/main">
             <a:pPr algn="ctr">
+              <a:buNone/>
               <a:defRPr sz="975" b="1">
                 <a:solidFill>
                   <a:srgbClr val="2563EB"/>
@@ -10814,6 +10961,7 @@
           <a:lstStyle xmlns:a="http://schemas.openxmlformats.org/drawingml/2006/main"/>
           <a:p xmlns:a="http://schemas.openxmlformats.org/drawingml/2006/main">
             <a:pPr algn="ctr">
+              <a:buNone/>
               <a:defRPr sz="825" b="0">
                 <a:solidFill>
                   <a:srgbClr val="334155"/>
@@ -10870,6 +11018,7 @@
           <a:lstStyle xmlns:a="http://schemas.openxmlformats.org/drawingml/2006/main"/>
           <a:p xmlns:a="http://schemas.openxmlformats.org/drawingml/2006/main">
             <a:pPr algn="ctr">
+              <a:buNone/>
               <a:defRPr sz="825" b="0">
                 <a:solidFill>
                   <a:srgbClr val="334155"/>
@@ -10926,6 +11075,7 @@
           <a:lstStyle xmlns:a="http://schemas.openxmlformats.org/drawingml/2006/main"/>
           <a:p xmlns:a="http://schemas.openxmlformats.org/drawingml/2006/main">
             <a:pPr algn="ctr">
+              <a:buNone/>
               <a:defRPr sz="825" b="0">
                 <a:solidFill>
                   <a:srgbClr val="334155"/>
@@ -10938,7 +11088,7 @@
                   <a:srgbClr val="334155"/>
                 </a:solidFill>
               </a:rPr>
-              <a:t>Fetch PC equals boot PC, no execute, no commit, no trap.</a:t>
+              <a:t>No execute, no commit, no trap while reset is active.</a:t>
             </a:r>
           </a:p>
         </p:txBody>
@@ -10982,6 +11132,7 @@
           <a:lstStyle xmlns:a="http://schemas.openxmlformats.org/drawingml/2006/main"/>
           <a:p xmlns:a="http://schemas.openxmlformats.org/drawingml/2006/main">
             <a:pPr algn="ctr">
+              <a:buNone/>
               <a:defRPr sz="825" b="0">
                 <a:solidFill>
                   <a:srgbClr val="334155"/>
@@ -11038,6 +11189,7 @@
           <a:lstStyle xmlns:a="http://schemas.openxmlformats.org/drawingml/2006/main"/>
           <a:p xmlns:a="http://schemas.openxmlformats.org/drawingml/2006/main">
             <a:pPr algn="ctr">
+              <a:buNone/>
               <a:defRPr sz="825" b="0">
                 <a:solidFill>
                   <a:srgbClr val="334155"/>
@@ -11094,6 +11246,7 @@
           <a:lstStyle xmlns:a="http://schemas.openxmlformats.org/drawingml/2006/main"/>
           <a:p xmlns:a="http://schemas.openxmlformats.org/drawingml/2006/main">
             <a:pPr algn="ctr">
+              <a:buNone/>
               <a:defRPr sz="825" b="0">
                 <a:solidFill>
                   <a:srgbClr val="334155"/>
@@ -11150,6 +11303,7 @@
           <a:lstStyle xmlns:a="http://schemas.openxmlformats.org/drawingml/2006/main"/>
           <a:p xmlns:a="http://schemas.openxmlformats.org/drawingml/2006/main">
             <a:pPr algn="ctr">
+              <a:buNone/>
               <a:defRPr sz="825" b="0">
                 <a:solidFill>
                   <a:srgbClr val="334155"/>
@@ -11206,6 +11360,7 @@
           <a:lstStyle xmlns:a="http://schemas.openxmlformats.org/drawingml/2006/main"/>
           <a:p xmlns:a="http://schemas.openxmlformats.org/drawingml/2006/main">
             <a:pPr algn="ctr">
+              <a:buNone/>
               <a:defRPr sz="825" b="0">
                 <a:solidFill>
                   <a:srgbClr val="334155"/>
@@ -11262,6 +11417,7 @@
           <a:lstStyle xmlns:a="http://schemas.openxmlformats.org/drawingml/2006/main"/>
           <a:p xmlns:a="http://schemas.openxmlformats.org/drawingml/2006/main">
             <a:pPr algn="ctr">
+              <a:buNone/>
               <a:defRPr sz="825" b="0">
                 <a:solidFill>
                   <a:srgbClr val="334155"/>
@@ -11318,6 +11474,7 @@
           <a:lstStyle xmlns:a="http://schemas.openxmlformats.org/drawingml/2006/main"/>
           <a:p xmlns:a="http://schemas.openxmlformats.org/drawingml/2006/main">
             <a:pPr algn="ctr">
+              <a:buNone/>
               <a:defRPr sz="825" b="0">
                 <a:solidFill>
                   <a:srgbClr val="334155"/>
@@ -11374,6 +11531,7 @@
           <a:lstStyle xmlns:a="http://schemas.openxmlformats.org/drawingml/2006/main"/>
           <a:p xmlns:a="http://schemas.openxmlformats.org/drawingml/2006/main">
             <a:pPr algn="ctr">
+              <a:buNone/>
               <a:defRPr sz="825" b="0">
                 <a:solidFill>
                   <a:srgbClr val="334155"/>
@@ -11430,6 +11588,7 @@
           <a:lstStyle xmlns:a="http://schemas.openxmlformats.org/drawingml/2006/main"/>
           <a:p xmlns:a="http://schemas.openxmlformats.org/drawingml/2006/main">
             <a:pPr algn="ctr">
+              <a:buNone/>
               <a:defRPr sz="825" b="0">
                 <a:solidFill>
                   <a:srgbClr val="334155"/>
@@ -11486,6 +11645,7 @@
           <a:lstStyle xmlns:a="http://schemas.openxmlformats.org/drawingml/2006/main"/>
           <a:p xmlns:a="http://schemas.openxmlformats.org/drawingml/2006/main">
             <a:pPr algn="ctr">
+              <a:buNone/>
               <a:defRPr sz="825" b="0">
                 <a:solidFill>
                   <a:srgbClr val="334155"/>
@@ -11542,6 +11702,7 @@
           <a:lstStyle xmlns:a="http://schemas.openxmlformats.org/drawingml/2006/main"/>
           <a:p xmlns:a="http://schemas.openxmlformats.org/drawingml/2006/main">
             <a:pPr algn="ctr">
+              <a:buNone/>
               <a:defRPr sz="825" b="0">
                 <a:solidFill>
                   <a:srgbClr val="334155"/>
@@ -11598,6 +11759,7 @@
           <a:lstStyle xmlns:a="http://schemas.openxmlformats.org/drawingml/2006/main"/>
           <a:p xmlns:a="http://schemas.openxmlformats.org/drawingml/2006/main">
             <a:pPr algn="ctr">
+              <a:buNone/>
               <a:defRPr sz="825" b="0">
                 <a:solidFill>
                   <a:srgbClr val="334155"/>
@@ -11654,6 +11816,7 @@
           <a:lstStyle xmlns:a="http://schemas.openxmlformats.org/drawingml/2006/main"/>
           <a:p xmlns:a="http://schemas.openxmlformats.org/drawingml/2006/main">
             <a:pPr algn="ctr">
+              <a:buNone/>
               <a:defRPr sz="825" b="0">
                 <a:solidFill>
                   <a:srgbClr val="334155"/>
@@ -11710,6 +11873,7 @@
           <a:lstStyle xmlns:a="http://schemas.openxmlformats.org/drawingml/2006/main"/>
           <a:p xmlns:a="http://schemas.openxmlformats.org/drawingml/2006/main">
             <a:pPr algn="ctr">
+              <a:buNone/>
               <a:defRPr sz="825" b="0">
                 <a:solidFill>
                   <a:srgbClr val="334155"/>
@@ -11766,6 +11930,7 @@
           <a:lstStyle xmlns:a="http://schemas.openxmlformats.org/drawingml/2006/main"/>
           <a:p xmlns:a="http://schemas.openxmlformats.org/drawingml/2006/main">
             <a:pPr algn="ctr">
+              <a:buNone/>
               <a:defRPr sz="825" b="0">
                 <a:solidFill>
                   <a:srgbClr val="334155"/>
@@ -11822,6 +11987,7 @@
           <a:lstStyle xmlns:a="http://schemas.openxmlformats.org/drawingml/2006/main"/>
           <a:p xmlns:a="http://schemas.openxmlformats.org/drawingml/2006/main">
             <a:pPr algn="ctr">
+              <a:buNone/>
               <a:defRPr sz="825" b="0">
                 <a:solidFill>
                   <a:srgbClr val="334155"/>
@@ -11834,7 +12000,7 @@
                   <a:srgbClr val="334155"/>
                 </a:solidFill>
               </a:rPr>
-              <a:t>Fetch PC equals boot PC; no execute, commit, or trap.</a:t>
+              <a:t>No execute, commit, or trap while reset is active.</a:t>
             </a:r>
           </a:p>
         </p:txBody>
@@ -11878,6 +12044,7 @@
           <a:lstStyle xmlns:a="http://schemas.openxmlformats.org/drawingml/2006/main"/>
           <a:p xmlns:a="http://schemas.openxmlformats.org/drawingml/2006/main">
             <a:pPr algn="ctr">
+              <a:buNone/>
               <a:defRPr sz="825" b="0">
                 <a:solidFill>
                   <a:srgbClr val="334155"/>
@@ -11928,6 +12095,7 @@
           <a:lstStyle xmlns:a="http://schemas.openxmlformats.org/drawingml/2006/main"/>
           <a:p xmlns:a="http://schemas.openxmlformats.org/drawingml/2006/main">
             <a:pPr algn="l">
+              <a:buNone/>
               <a:defRPr sz="1200" b="0">
                 <a:solidFill>
                   <a:srgbClr val="64748B"/>
@@ -11978,6 +12146,7 @@
           <a:lstStyle xmlns:a="http://schemas.openxmlformats.org/drawingml/2006/main"/>
           <a:p xmlns:a="http://schemas.openxmlformats.org/drawingml/2006/main">
             <a:pPr algn="l">
+              <a:buNone/>
               <a:defRPr sz="750" b="0">
                 <a:solidFill>
                   <a:srgbClr val="64748B"/>
@@ -12028,6 +12197,7 @@
           <a:lstStyle xmlns:a="http://schemas.openxmlformats.org/drawingml/2006/main"/>
           <a:p xmlns:a="http://schemas.openxmlformats.org/drawingml/2006/main">
             <a:pPr algn="r">
+              <a:buNone/>
               <a:defRPr sz="750" b="0">
                 <a:solidFill>
                   <a:srgbClr val="64748B"/>
@@ -12107,6 +12277,7 @@
           <a:lstStyle xmlns:a="http://schemas.openxmlformats.org/drawingml/2006/main"/>
           <a:p xmlns:a="http://schemas.openxmlformats.org/drawingml/2006/main">
             <a:pPr algn="l">
+              <a:buNone/>
               <a:defRPr sz="900" b="1">
                 <a:solidFill>
                   <a:srgbClr val="2563EB"/>
@@ -12157,6 +12328,7 @@
           <a:lstStyle xmlns:a="http://schemas.openxmlformats.org/drawingml/2006/main"/>
           <a:p xmlns:a="http://schemas.openxmlformats.org/drawingml/2006/main">
             <a:pPr algn="l">
+              <a:buNone/>
               <a:defRPr sz="2400" b="1">
                 <a:solidFill>
                   <a:srgbClr val="111827"/>
@@ -12207,6 +12379,7 @@
           <a:lstStyle xmlns:a="http://schemas.openxmlformats.org/drawingml/2006/main"/>
           <a:p xmlns:a="http://schemas.openxmlformats.org/drawingml/2006/main">
             <a:pPr algn="l">
+              <a:buNone/>
               <a:defRPr sz="975" b="0">
                 <a:solidFill>
                   <a:srgbClr val="334155"/>
@@ -12327,6 +12500,7 @@
           <a:lstStyle xmlns:a="http://schemas.openxmlformats.org/drawingml/2006/main"/>
           <a:p xmlns:a="http://schemas.openxmlformats.org/drawingml/2006/main">
             <a:pPr algn="l">
+              <a:buNone/>
               <a:defRPr sz="900" b="1">
                 <a:solidFill>
                   <a:srgbClr val="16A34A"/>
@@ -12377,6 +12551,7 @@
           <a:lstStyle xmlns:a="http://schemas.openxmlformats.org/drawingml/2006/main"/>
           <a:p xmlns:a="http://schemas.openxmlformats.org/drawingml/2006/main">
             <a:pPr algn="l">
+              <a:buNone/>
               <a:defRPr sz="975" b="0">
                 <a:solidFill>
                   <a:srgbClr val="334155"/>
@@ -12497,6 +12672,7 @@
           <a:lstStyle xmlns:a="http://schemas.openxmlformats.org/drawingml/2006/main"/>
           <a:p xmlns:a="http://schemas.openxmlformats.org/drawingml/2006/main">
             <a:pPr algn="l">
+              <a:buNone/>
               <a:defRPr sz="900" b="1">
                 <a:solidFill>
                   <a:srgbClr val="2563EB"/>
@@ -12547,6 +12723,7 @@
           <a:lstStyle xmlns:a="http://schemas.openxmlformats.org/drawingml/2006/main"/>
           <a:p xmlns:a="http://schemas.openxmlformats.org/drawingml/2006/main">
             <a:pPr algn="l">
+              <a:buNone/>
               <a:defRPr sz="975" b="0">
                 <a:solidFill>
                   <a:srgbClr val="334155"/>
@@ -12667,6 +12844,7 @@
           <a:lstStyle xmlns:a="http://schemas.openxmlformats.org/drawingml/2006/main"/>
           <a:p xmlns:a="http://schemas.openxmlformats.org/drawingml/2006/main">
             <a:pPr algn="l">
+              <a:buNone/>
               <a:defRPr sz="900" b="1">
                 <a:solidFill>
                   <a:srgbClr val="D97706"/>
@@ -12717,6 +12895,7 @@
           <a:lstStyle xmlns:a="http://schemas.openxmlformats.org/drawingml/2006/main"/>
           <a:p xmlns:a="http://schemas.openxmlformats.org/drawingml/2006/main">
             <a:pPr algn="l">
+              <a:buNone/>
               <a:defRPr sz="975" b="0">
                 <a:solidFill>
                   <a:srgbClr val="334155"/>
@@ -12837,6 +13016,7 @@
           <a:lstStyle xmlns:a="http://schemas.openxmlformats.org/drawingml/2006/main"/>
           <a:p xmlns:a="http://schemas.openxmlformats.org/drawingml/2006/main">
             <a:pPr algn="l">
+              <a:buNone/>
               <a:defRPr sz="900" b="1">
                 <a:solidFill>
                   <a:srgbClr val="7C3AED"/>
@@ -12887,6 +13067,7 @@
           <a:lstStyle xmlns:a="http://schemas.openxmlformats.org/drawingml/2006/main"/>
           <a:p xmlns:a="http://schemas.openxmlformats.org/drawingml/2006/main">
             <a:pPr algn="l">
+              <a:buNone/>
               <a:defRPr sz="975" b="0">
                 <a:solidFill>
                   <a:srgbClr val="334155"/>
@@ -13007,6 +13188,7 @@
           <a:lstStyle xmlns:a="http://schemas.openxmlformats.org/drawingml/2006/main"/>
           <a:p xmlns:a="http://schemas.openxmlformats.org/drawingml/2006/main">
             <a:pPr algn="l">
+              <a:buNone/>
               <a:defRPr sz="900" b="1">
                 <a:solidFill>
                   <a:srgbClr val="16A34A"/>
@@ -13057,6 +13239,7 @@
           <a:lstStyle xmlns:a="http://schemas.openxmlformats.org/drawingml/2006/main"/>
           <a:p xmlns:a="http://schemas.openxmlformats.org/drawingml/2006/main">
             <a:pPr algn="l">
+              <a:buNone/>
               <a:defRPr sz="975" b="0">
                 <a:solidFill>
                   <a:srgbClr val="334155"/>
@@ -13177,6 +13360,7 @@
           <a:lstStyle xmlns:a="http://schemas.openxmlformats.org/drawingml/2006/main"/>
           <a:p xmlns:a="http://schemas.openxmlformats.org/drawingml/2006/main">
             <a:pPr algn="l">
+              <a:buNone/>
               <a:defRPr sz="900" b="1">
                 <a:solidFill>
                   <a:srgbClr val="2563EB"/>
@@ -13233,6 +13417,7 @@
           <a:lstStyle xmlns:a="http://schemas.openxmlformats.org/drawingml/2006/main"/>
           <a:p xmlns:a="http://schemas.openxmlformats.org/drawingml/2006/main">
             <a:pPr algn="ctr">
+              <a:buNone/>
               <a:defRPr sz="1650" b="1">
                 <a:solidFill>
                   <a:srgbClr val="16A34A"/>
@@ -13318,6 +13503,7 @@
           <a:lstStyle xmlns:a="http://schemas.openxmlformats.org/drawingml/2006/main"/>
           <a:p xmlns:a="http://schemas.openxmlformats.org/drawingml/2006/main">
             <a:pPr algn="l">
+              <a:buNone/>
               <a:defRPr sz="1200" b="0">
                 <a:solidFill>
                   <a:srgbClr val="334155"/>
@@ -13403,6 +13589,7 @@
           <a:lstStyle xmlns:a="http://schemas.openxmlformats.org/drawingml/2006/main"/>
           <a:p xmlns:a="http://schemas.openxmlformats.org/drawingml/2006/main">
             <a:pPr algn="l">
+              <a:buNone/>
               <a:defRPr sz="1200" b="0">
                 <a:solidFill>
                   <a:srgbClr val="334155"/>
@@ -13488,6 +13675,7 @@
           <a:lstStyle xmlns:a="http://schemas.openxmlformats.org/drawingml/2006/main"/>
           <a:p xmlns:a="http://schemas.openxmlformats.org/drawingml/2006/main">
             <a:pPr algn="l">
+              <a:buNone/>
               <a:defRPr sz="1200" b="0">
                 <a:solidFill>
                   <a:srgbClr val="334155"/>
@@ -13573,6 +13761,7 @@
           <a:lstStyle xmlns:a="http://schemas.openxmlformats.org/drawingml/2006/main"/>
           <a:p xmlns:a="http://schemas.openxmlformats.org/drawingml/2006/main">
             <a:pPr algn="l">
+              <a:buNone/>
               <a:defRPr sz="1200" b="0">
                 <a:solidFill>
                   <a:srgbClr val="334155"/>
@@ -13629,6 +13818,7 @@
           <a:lstStyle xmlns:a="http://schemas.openxmlformats.org/drawingml/2006/main"/>
           <a:p xmlns:a="http://schemas.openxmlformats.org/drawingml/2006/main">
             <a:pPr algn="ctr">
+              <a:buNone/>
               <a:defRPr sz="1200" b="1">
                 <a:solidFill>
                   <a:srgbClr val="D97706"/>
@@ -13679,6 +13869,7 @@
           <a:lstStyle xmlns:a="http://schemas.openxmlformats.org/drawingml/2006/main"/>
           <a:p xmlns:a="http://schemas.openxmlformats.org/drawingml/2006/main">
             <a:pPr algn="l">
+              <a:buNone/>
               <a:defRPr sz="750" b="0">
                 <a:solidFill>
                   <a:srgbClr val="64748B"/>
@@ -13729,6 +13920,7 @@
           <a:lstStyle xmlns:a="http://schemas.openxmlformats.org/drawingml/2006/main"/>
           <a:p xmlns:a="http://schemas.openxmlformats.org/drawingml/2006/main">
             <a:pPr algn="r">
+              <a:buNone/>
               <a:defRPr sz="750" b="0">
                 <a:solidFill>
                   <a:srgbClr val="64748B"/>

</xml_diff>

<commit_message>
Add core data valid-ready handshake
</commit_message>
<xml_diff>
--- a/core/docs/wasp1_core_design.pptx
+++ b/core/docs/wasp1_core_design.pptx
@@ -2,22 +2,22 @@
 <file path=ppt/presentation.xml><?xml version="1.0" encoding="utf-8"?>
 <p:presentation xmlns:p="http://schemas.openxmlformats.org/presentationml/2006/main">
   <p:sldMasterIdLst>
-    <p:sldMasterId xmlns:r="http://schemas.openxmlformats.org/officeDocument/2006/relationships" id="2147483648" r:id="R70576c2ba35b4c22"/>
+    <p:sldMasterId xmlns:r="http://schemas.openxmlformats.org/officeDocument/2006/relationships" id="2147483648" r:id="R2853e3aa6b9b4dc8"/>
   </p:sldMasterIdLst>
   <p:notesMasterIdLst>
-    <p:notesMasterId xmlns:r="http://schemas.openxmlformats.org/officeDocument/2006/relationships" r:id="Rec9da2b17e304f66"/>
+    <p:notesMasterId xmlns:r="http://schemas.openxmlformats.org/officeDocument/2006/relationships" r:id="Rda2b4f36c9a14ad9"/>
   </p:notesMasterIdLst>
   <p:sldIdLst>
-    <p:sldId xmlns:r="http://schemas.openxmlformats.org/officeDocument/2006/relationships" id="256" r:id="R4c554a9600a54730"/>
-    <p:sldId xmlns:r="http://schemas.openxmlformats.org/officeDocument/2006/relationships" id="257" r:id="R2c3067a2150e4a61"/>
-    <p:sldId xmlns:r="http://schemas.openxmlformats.org/officeDocument/2006/relationships" id="258" r:id="R9fabb11f42a44707"/>
-    <p:sldId xmlns:r="http://schemas.openxmlformats.org/officeDocument/2006/relationships" id="259" r:id="R5c2cf8d49e6e4c4d"/>
-    <p:sldId xmlns:r="http://schemas.openxmlformats.org/officeDocument/2006/relationships" id="260" r:id="Rda22d637fe324ff8"/>
-    <p:sldId xmlns:r="http://schemas.openxmlformats.org/officeDocument/2006/relationships" id="261" r:id="Ra2ae432d37284797"/>
-    <p:sldId xmlns:r="http://schemas.openxmlformats.org/officeDocument/2006/relationships" id="262" r:id="Rf30e0c42fd8743cf"/>
-    <p:sldId xmlns:r="http://schemas.openxmlformats.org/officeDocument/2006/relationships" id="263" r:id="Re18625b112034d3e"/>
-    <p:sldId xmlns:r="http://schemas.openxmlformats.org/officeDocument/2006/relationships" id="264" r:id="R808033081aa04dfb"/>
-    <p:sldId xmlns:r="http://schemas.openxmlformats.org/officeDocument/2006/relationships" id="265" r:id="Rbbcd00b0bf1040c7"/>
+    <p:sldId xmlns:r="http://schemas.openxmlformats.org/officeDocument/2006/relationships" id="256" r:id="R140ab775373a49fe"/>
+    <p:sldId xmlns:r="http://schemas.openxmlformats.org/officeDocument/2006/relationships" id="257" r:id="R19bb956091804089"/>
+    <p:sldId xmlns:r="http://schemas.openxmlformats.org/officeDocument/2006/relationships" id="258" r:id="Re41e1f4ef6e84181"/>
+    <p:sldId xmlns:r="http://schemas.openxmlformats.org/officeDocument/2006/relationships" id="259" r:id="R7108ded29d954de2"/>
+    <p:sldId xmlns:r="http://schemas.openxmlformats.org/officeDocument/2006/relationships" id="260" r:id="Rc53b27a1e09d4157"/>
+    <p:sldId xmlns:r="http://schemas.openxmlformats.org/officeDocument/2006/relationships" id="261" r:id="Rda4ece762efd4f66"/>
+    <p:sldId xmlns:r="http://schemas.openxmlformats.org/officeDocument/2006/relationships" id="262" r:id="Ra34b9a98f7ff42fd"/>
+    <p:sldId xmlns:r="http://schemas.openxmlformats.org/officeDocument/2006/relationships" id="263" r:id="R0dd37a5e86f04131"/>
+    <p:sldId xmlns:r="http://schemas.openxmlformats.org/officeDocument/2006/relationships" id="264" r:id="Rbfe88c52ba3d4496"/>
+    <p:sldId xmlns:r="http://schemas.openxmlformats.org/officeDocument/2006/relationships" id="265" r:id="Rea52af0c35434ab1"/>
   </p:sldIdLst>
   <p:sldSz cx="12192000" cy="6858000"/>
   <p:notesSz cx="6858000" cy="9144000"/>
@@ -1204,7 +1204,7 @@
   </p:cSld>
   <p:clrMap bg1="lt1" tx1="dk1" bg2="lt2" tx2="dk2" accent1="accent1" accent2="accent2" accent3="accent3" accent4="accent4" accent5="accent5" accent6="accent6" hlink="hlink" folHlink="folHlink"/>
   <p:sldLayoutIdLst>
-    <p:sldLayoutId xmlns:r="http://schemas.openxmlformats.org/officeDocument/2006/relationships" id="2147483649" r:id="Rf51c0502d3c24683"/>
+    <p:sldLayoutId xmlns:r="http://schemas.openxmlformats.org/officeDocument/2006/relationships" id="2147483649" r:id="R6aa07814aaaa4e05"/>
   </p:sldLayoutIdLst>
   <p:txStyles>
     <p:titleStyle>
@@ -2784,7 +2784,7 @@
                   <a:srgbClr val="2563EB"/>
                 </a:solidFill>
               </a:rPr>
-              <a:t>IF staged</a:t>
+              <a:t>IF V/R</a:t>
             </a:r>
           </a:p>
         </p:txBody>
@@ -7568,7 +7568,7 @@
                   <a:srgbClr val="2563EB"/>
                 </a:solidFill>
               </a:rPr>
-              <a:t>IF staged</a:t>
+              <a:t>IF V/R</a:t>
             </a:r>
           </a:p>
         </p:txBody>
@@ -9246,11 +9246,11 @@
           <p:nvPr/>
         </p:nvPicPr>
         <p:blipFill>
-          <a:blip xmlns:r="http://schemas.openxmlformats.org/officeDocument/2006/relationships" xmlns:a="http://schemas.openxmlformats.org/drawingml/2006/main" r:embed="R8a222234773e4f7d"/>
+          <a:blip xmlns:r="http://schemas.openxmlformats.org/officeDocument/2006/relationships" xmlns:a="http://schemas.openxmlformats.org/drawingml/2006/main" r:embed="R4977851ce50144eb"/>
           <a:stretch xmlns:a="http://schemas.openxmlformats.org/drawingml/2006/main"/>
         </p:blipFill>
         <p:spPr>
-          <a:xfrm xmlns:a="http://schemas.openxmlformats.org/drawingml/2006/main">
+          <a:xfrm xmlns:a="http://schemas.openxmlformats.org/drawingml/2006/main" flipH="0" flipV="0">
             <a:off x="571500" y="1553766"/>
             <a:ext cx="3429000" cy="2035969"/>
           </a:xfrm>
@@ -9268,11 +9268,11 @@
           <p:nvPr/>
         </p:nvPicPr>
         <p:blipFill>
-          <a:blip xmlns:r="http://schemas.openxmlformats.org/officeDocument/2006/relationships" xmlns:a="http://schemas.openxmlformats.org/drawingml/2006/main" r:embed="Rc6bdd8839a9f426f"/>
+          <a:blip xmlns:r="http://schemas.openxmlformats.org/officeDocument/2006/relationships" xmlns:a="http://schemas.openxmlformats.org/drawingml/2006/main" r:embed="R6f17ff8d26da419a"/>
           <a:stretch xmlns:a="http://schemas.openxmlformats.org/drawingml/2006/main"/>
         </p:blipFill>
         <p:spPr>
-          <a:xfrm xmlns:a="http://schemas.openxmlformats.org/drawingml/2006/main">
+          <a:xfrm xmlns:a="http://schemas.openxmlformats.org/drawingml/2006/main" flipH="0" flipV="0">
             <a:off x="4391853" y="1381125"/>
             <a:ext cx="3313043" cy="2381250"/>
           </a:xfrm>
@@ -9290,11 +9290,11 @@
           <p:nvPr/>
         </p:nvPicPr>
         <p:blipFill>
-          <a:blip xmlns:r="http://schemas.openxmlformats.org/officeDocument/2006/relationships" xmlns:a="http://schemas.openxmlformats.org/drawingml/2006/main" r:embed="Rca2168bfe37d4201"/>
+          <a:blip xmlns:r="http://schemas.openxmlformats.org/officeDocument/2006/relationships" xmlns:a="http://schemas.openxmlformats.org/drawingml/2006/main" r:embed="R44a3bc509b114cf7"/>
           <a:stretch xmlns:a="http://schemas.openxmlformats.org/drawingml/2006/main"/>
         </p:blipFill>
         <p:spPr>
-          <a:xfrm xmlns:a="http://schemas.openxmlformats.org/drawingml/2006/main">
+          <a:xfrm xmlns:a="http://schemas.openxmlformats.org/drawingml/2006/main" flipH="0" flipV="0">
             <a:off x="640773" y="4000500"/>
             <a:ext cx="3290455" cy="1905000"/>
           </a:xfrm>
@@ -9312,7 +9312,7 @@
           <p:nvPr/>
         </p:nvPicPr>
         <p:blipFill>
-          <a:blip xmlns:r="http://schemas.openxmlformats.org/officeDocument/2006/relationships" xmlns:a="http://schemas.openxmlformats.org/drawingml/2006/main" r:embed="R83a1ec87f46341e4"/>
+          <a:blip xmlns:r="http://schemas.openxmlformats.org/officeDocument/2006/relationships" xmlns:a="http://schemas.openxmlformats.org/drawingml/2006/main" r:embed="Rfa05b14d0c92464f"/>
           <a:stretch xmlns:a="http://schemas.openxmlformats.org/drawingml/2006/main"/>
         </p:blipFill>
         <p:spPr>

</xml_diff>